<commit_message>
update 01 and add 06-1 taller constructores
</commit_message>
<xml_diff>
--- a/01.POO.pptx
+++ b/01.POO.pptx
@@ -5,7 +5,7 @@
     <p:sldMasterId id="2147483653" r:id="rId1"/>
   </p:sldMasterIdLst>
   <p:notesMasterIdLst>
-    <p:notesMasterId r:id="rId45"/>
+    <p:notesMasterId r:id="rId49"/>
   </p:notesMasterIdLst>
   <p:sldIdLst>
     <p:sldId id="256" r:id="rId2"/>
@@ -46,11 +46,15 @@
     <p:sldId id="310" r:id="rId37"/>
     <p:sldId id="311" r:id="rId38"/>
     <p:sldId id="312" r:id="rId39"/>
-    <p:sldId id="313" r:id="rId40"/>
-    <p:sldId id="292" r:id="rId41"/>
-    <p:sldId id="262" r:id="rId42"/>
-    <p:sldId id="264" r:id="rId43"/>
-    <p:sldId id="265" r:id="rId44"/>
+    <p:sldId id="315" r:id="rId40"/>
+    <p:sldId id="314" r:id="rId41"/>
+    <p:sldId id="317" r:id="rId42"/>
+    <p:sldId id="316" r:id="rId43"/>
+    <p:sldId id="313" r:id="rId44"/>
+    <p:sldId id="292" r:id="rId45"/>
+    <p:sldId id="262" r:id="rId46"/>
+    <p:sldId id="264" r:id="rId47"/>
+    <p:sldId id="265" r:id="rId48"/>
   </p:sldIdLst>
   <p:sldSz cx="9144000" cy="6858000" type="screen4x3"/>
   <p:notesSz cx="6858000" cy="9144000"/>
@@ -212,12 +216,20 @@
 </p:presentation>
 </file>
 
+<file path=ppt/revisionInfo.xml><?xml version="1.0" encoding="utf-8"?>
+<p1510:revInfo xmlns:a="http://schemas.openxmlformats.org/drawingml/2006/main" xmlns:r="http://schemas.openxmlformats.org/officeDocument/2006/relationships" xmlns:p1510="http://schemas.microsoft.com/office/powerpoint/2015/10/main">
+  <p1510:revLst>
+    <p1510:client id="{9D437329-ECE3-4B1F-A5E4-A8B00831AD2B}" v="4" dt="2026-06-10T03:33:01.875"/>
+  </p1510:revLst>
+</p1510:revInfo>
+</file>
+
 <file path=ppt/changesInfos/changesInfo1.xml><?xml version="1.0" encoding="utf-8"?>
 <pc:chgInfo xmlns:a="http://schemas.openxmlformats.org/drawingml/2006/main" xmlns:r="http://schemas.openxmlformats.org/officeDocument/2006/relationships" xmlns:ac="http://schemas.microsoft.com/office/drawing/2013/main/command" xmlns:pc="http://schemas.microsoft.com/office/powerpoint/2013/main/command">
   <pc:docChgLst>
     <pc:chgData name="Norbey Muñoz" userId="b7e811e8891ccd42" providerId="LiveId" clId="{2482167B-ADD3-4E68-AB8B-ADE9CECE27D0}"/>
     <pc:docChg chg="undo custSel addSld delSld modSld sldOrd">
-      <pc:chgData name="Norbey Muñoz" userId="b7e811e8891ccd42" providerId="LiveId" clId="{2482167B-ADD3-4E68-AB8B-ADE9CECE27D0}" dt="2026-06-03T04:52:41.179" v="634" actId="47"/>
+      <pc:chgData name="Norbey Muñoz" userId="b7e811e8891ccd42" providerId="LiveId" clId="{2482167B-ADD3-4E68-AB8B-ADE9CECE27D0}" dt="2026-06-10T03:33:25.530" v="661"/>
       <pc:docMkLst>
         <pc:docMk/>
       </pc:docMkLst>
@@ -380,55 +392,6 @@
           <pc:sldMk cId="0" sldId="265"/>
         </pc:sldMkLst>
       </pc:sldChg>
-      <pc:sldChg chg="del">
-        <pc:chgData name="Norbey Muñoz" userId="b7e811e8891ccd42" providerId="LiveId" clId="{2482167B-ADD3-4E68-AB8B-ADE9CECE27D0}" dt="2026-06-03T04:52:30.971" v="620" actId="47"/>
-        <pc:sldMkLst>
-          <pc:docMk/>
-          <pc:sldMk cId="0" sldId="266"/>
-        </pc:sldMkLst>
-      </pc:sldChg>
-      <pc:sldChg chg="modSp del mod">
-        <pc:chgData name="Norbey Muñoz" userId="b7e811e8891ccd42" providerId="LiveId" clId="{2482167B-ADD3-4E68-AB8B-ADE9CECE27D0}" dt="2026-06-03T04:52:31.365" v="621" actId="47"/>
-        <pc:sldMkLst>
-          <pc:docMk/>
-          <pc:sldMk cId="0" sldId="267"/>
-        </pc:sldMkLst>
-      </pc:sldChg>
-      <pc:sldChg chg="modSp del mod">
-        <pc:chgData name="Norbey Muñoz" userId="b7e811e8891ccd42" providerId="LiveId" clId="{2482167B-ADD3-4E68-AB8B-ADE9CECE27D0}" dt="2026-06-03T04:52:32.489" v="622" actId="47"/>
-        <pc:sldMkLst>
-          <pc:docMk/>
-          <pc:sldMk cId="0" sldId="268"/>
-        </pc:sldMkLst>
-      </pc:sldChg>
-      <pc:sldChg chg="modSp del mod modShow">
-        <pc:chgData name="Norbey Muñoz" userId="b7e811e8891ccd42" providerId="LiveId" clId="{2482167B-ADD3-4E68-AB8B-ADE9CECE27D0}" dt="2026-06-03T04:52:32.875" v="623" actId="47"/>
-        <pc:sldMkLst>
-          <pc:docMk/>
-          <pc:sldMk cId="0" sldId="269"/>
-        </pc:sldMkLst>
-      </pc:sldChg>
-      <pc:sldChg chg="del">
-        <pc:chgData name="Norbey Muñoz" userId="b7e811e8891ccd42" providerId="LiveId" clId="{2482167B-ADD3-4E68-AB8B-ADE9CECE27D0}" dt="2026-06-03T04:52:34.753" v="625" actId="47"/>
-        <pc:sldMkLst>
-          <pc:docMk/>
-          <pc:sldMk cId="0" sldId="270"/>
-        </pc:sldMkLst>
-      </pc:sldChg>
-      <pc:sldChg chg="del">
-        <pc:chgData name="Norbey Muñoz" userId="b7e811e8891ccd42" providerId="LiveId" clId="{2482167B-ADD3-4E68-AB8B-ADE9CECE27D0}" dt="2026-06-03T04:52:35.133" v="626" actId="47"/>
-        <pc:sldMkLst>
-          <pc:docMk/>
-          <pc:sldMk cId="0" sldId="271"/>
-        </pc:sldMkLst>
-      </pc:sldChg>
-      <pc:sldChg chg="del">
-        <pc:chgData name="Norbey Muñoz" userId="b7e811e8891ccd42" providerId="LiveId" clId="{2482167B-ADD3-4E68-AB8B-ADE9CECE27D0}" dt="2026-06-03T04:52:35.545" v="627" actId="47"/>
-        <pc:sldMkLst>
-          <pc:docMk/>
-          <pc:sldMk cId="0" sldId="272"/>
-        </pc:sldMkLst>
-      </pc:sldChg>
       <pc:sldChg chg="addSp modSp mod modAnim">
         <pc:chgData name="Norbey Muñoz" userId="b7e811e8891ccd42" providerId="LiveId" clId="{2482167B-ADD3-4E68-AB8B-ADE9CECE27D0}" dt="2026-05-22T12:55:53.632" v="231"/>
         <pc:sldMkLst>
@@ -507,62 +470,6 @@
             <ac:grpSpMk id="65566" creationId="{C818E870-964D-D3D2-4F26-C2B71EC5A0B3}"/>
           </ac:grpSpMkLst>
         </pc:grpChg>
-      </pc:sldChg>
-      <pc:sldChg chg="del">
-        <pc:chgData name="Norbey Muñoz" userId="b7e811e8891ccd42" providerId="LiveId" clId="{2482167B-ADD3-4E68-AB8B-ADE9CECE27D0}" dt="2026-06-03T04:52:36.108" v="628" actId="47"/>
-        <pc:sldMkLst>
-          <pc:docMk/>
-          <pc:sldMk cId="0" sldId="274"/>
-        </pc:sldMkLst>
-      </pc:sldChg>
-      <pc:sldChg chg="del">
-        <pc:chgData name="Norbey Muñoz" userId="b7e811e8891ccd42" providerId="LiveId" clId="{2482167B-ADD3-4E68-AB8B-ADE9CECE27D0}" dt="2026-06-03T04:52:36.791" v="629" actId="47"/>
-        <pc:sldMkLst>
-          <pc:docMk/>
-          <pc:sldMk cId="0" sldId="275"/>
-        </pc:sldMkLst>
-      </pc:sldChg>
-      <pc:sldChg chg="del">
-        <pc:chgData name="Norbey Muñoz" userId="b7e811e8891ccd42" providerId="LiveId" clId="{2482167B-ADD3-4E68-AB8B-ADE9CECE27D0}" dt="2026-06-03T04:52:37.228" v="630" actId="47"/>
-        <pc:sldMkLst>
-          <pc:docMk/>
-          <pc:sldMk cId="0" sldId="276"/>
-        </pc:sldMkLst>
-      </pc:sldChg>
-      <pc:sldChg chg="del">
-        <pc:chgData name="Norbey Muñoz" userId="b7e811e8891ccd42" providerId="LiveId" clId="{2482167B-ADD3-4E68-AB8B-ADE9CECE27D0}" dt="2026-06-03T04:52:37.706" v="631" actId="47"/>
-        <pc:sldMkLst>
-          <pc:docMk/>
-          <pc:sldMk cId="0" sldId="277"/>
-        </pc:sldMkLst>
-      </pc:sldChg>
-      <pc:sldChg chg="del">
-        <pc:chgData name="Norbey Muñoz" userId="b7e811e8891ccd42" providerId="LiveId" clId="{2482167B-ADD3-4E68-AB8B-ADE9CECE27D0}" dt="2026-06-03T04:52:39.309" v="632" actId="47"/>
-        <pc:sldMkLst>
-          <pc:docMk/>
-          <pc:sldMk cId="0" sldId="278"/>
-        </pc:sldMkLst>
-      </pc:sldChg>
-      <pc:sldChg chg="del">
-        <pc:chgData name="Norbey Muñoz" userId="b7e811e8891ccd42" providerId="LiveId" clId="{2482167B-ADD3-4E68-AB8B-ADE9CECE27D0}" dt="2026-06-03T04:52:40.285" v="633" actId="47"/>
-        <pc:sldMkLst>
-          <pc:docMk/>
-          <pc:sldMk cId="0" sldId="279"/>
-        </pc:sldMkLst>
-      </pc:sldChg>
-      <pc:sldChg chg="del">
-        <pc:chgData name="Norbey Muñoz" userId="b7e811e8891ccd42" providerId="LiveId" clId="{2482167B-ADD3-4E68-AB8B-ADE9CECE27D0}" dt="2026-06-03T04:52:41.179" v="634" actId="47"/>
-        <pc:sldMkLst>
-          <pc:docMk/>
-          <pc:sldMk cId="0" sldId="280"/>
-        </pc:sldMkLst>
-      </pc:sldChg>
-      <pc:sldChg chg="del">
-        <pc:chgData name="Norbey Muñoz" userId="b7e811e8891ccd42" providerId="LiveId" clId="{2482167B-ADD3-4E68-AB8B-ADE9CECE27D0}" dt="2026-06-03T04:52:34.279" v="624" actId="47"/>
-        <pc:sldMkLst>
-          <pc:docMk/>
-          <pc:sldMk cId="0" sldId="281"/>
-        </pc:sldMkLst>
       </pc:sldChg>
       <pc:sldChg chg="modSp mod">
         <pc:chgData name="Norbey Muñoz" userId="b7e811e8891ccd42" providerId="LiveId" clId="{2482167B-ADD3-4E68-AB8B-ADE9CECE27D0}" dt="2026-05-22T12:41:24.460" v="90" actId="33524"/>
@@ -1231,17 +1138,25 @@
         </pc:picChg>
       </pc:sldChg>
       <pc:sldChg chg="addSp delSp modSp add mod">
-        <pc:chgData name="Norbey Muñoz" userId="b7e811e8891ccd42" providerId="LiveId" clId="{2482167B-ADD3-4E68-AB8B-ADE9CECE27D0}" dt="2026-05-29T12:52:56.725" v="606" actId="1076"/>
+        <pc:chgData name="Norbey Muñoz" userId="b7e811e8891ccd42" providerId="LiveId" clId="{2482167B-ADD3-4E68-AB8B-ADE9CECE27D0}" dt="2026-06-10T03:18:59.975" v="639" actId="1076"/>
         <pc:sldMkLst>
           <pc:docMk/>
           <pc:sldMk cId="1869973127" sldId="312"/>
         </pc:sldMkLst>
-        <pc:picChg chg="add mod">
-          <ac:chgData name="Norbey Muñoz" userId="b7e811e8891ccd42" providerId="LiveId" clId="{2482167B-ADD3-4E68-AB8B-ADE9CECE27D0}" dt="2026-05-29T12:52:56.725" v="606" actId="1076"/>
+        <pc:picChg chg="add del mod">
+          <ac:chgData name="Norbey Muñoz" userId="b7e811e8891ccd42" providerId="LiveId" clId="{2482167B-ADD3-4E68-AB8B-ADE9CECE27D0}" dt="2026-06-10T03:18:52.825" v="636" actId="478"/>
           <ac:picMkLst>
             <pc:docMk/>
             <pc:sldMk cId="1869973127" sldId="312"/>
             <ac:picMk id="2" creationId="{016E6150-4D5E-0C58-A5AC-B60A4C0BD3A0}"/>
+          </ac:picMkLst>
+        </pc:picChg>
+        <pc:picChg chg="add mod">
+          <ac:chgData name="Norbey Muñoz" userId="b7e811e8891ccd42" providerId="LiveId" clId="{2482167B-ADD3-4E68-AB8B-ADE9CECE27D0}" dt="2026-06-10T03:18:59.975" v="639" actId="1076"/>
+          <ac:picMkLst>
+            <pc:docMk/>
+            <pc:sldMk cId="1869973127" sldId="312"/>
+            <ac:picMk id="3" creationId="{725C6B60-5B5F-2656-8A5A-E43F557018CB}"/>
           </ac:picMkLst>
         </pc:picChg>
       </pc:sldChg>
@@ -1273,6 +1188,82 @@
             <pc:docMk/>
             <pc:sldMk cId="955635252" sldId="313"/>
             <ac:picMk id="5" creationId="{B012B65A-472D-355E-EF48-92A0A543F014}"/>
+          </ac:picMkLst>
+        </pc:picChg>
+      </pc:sldChg>
+      <pc:sldChg chg="addSp delSp modSp add mod">
+        <pc:chgData name="Norbey Muñoz" userId="b7e811e8891ccd42" providerId="LiveId" clId="{2482167B-ADD3-4E68-AB8B-ADE9CECE27D0}" dt="2026-06-10T03:32:01.372" v="649" actId="1076"/>
+        <pc:sldMkLst>
+          <pc:docMk/>
+          <pc:sldMk cId="3878874060" sldId="314"/>
+        </pc:sldMkLst>
+        <pc:picChg chg="del">
+          <ac:chgData name="Norbey Muñoz" userId="b7e811e8891ccd42" providerId="LiveId" clId="{2482167B-ADD3-4E68-AB8B-ADE9CECE27D0}" dt="2026-06-10T03:31:55.358" v="646" actId="478"/>
+          <ac:picMkLst>
+            <pc:docMk/>
+            <pc:sldMk cId="3878874060" sldId="314"/>
+            <ac:picMk id="2" creationId="{0CAAB041-2B13-3A48-A94D-31B2AA4BA7C0}"/>
+          </ac:picMkLst>
+        </pc:picChg>
+        <pc:picChg chg="add mod">
+          <ac:chgData name="Norbey Muñoz" userId="b7e811e8891ccd42" providerId="LiveId" clId="{2482167B-ADD3-4E68-AB8B-ADE9CECE27D0}" dt="2026-06-10T03:32:01.372" v="649" actId="1076"/>
+          <ac:picMkLst>
+            <pc:docMk/>
+            <pc:sldMk cId="3878874060" sldId="314"/>
+            <ac:picMk id="3" creationId="{441E7974-167E-57CF-0509-7A3AEDAEC10F}"/>
+          </ac:picMkLst>
+        </pc:picChg>
+      </pc:sldChg>
+      <pc:sldChg chg="addSp delSp modSp add mod">
+        <pc:chgData name="Norbey Muñoz" userId="b7e811e8891ccd42" providerId="LiveId" clId="{2482167B-ADD3-4E68-AB8B-ADE9CECE27D0}" dt="2026-06-10T03:31:27.404" v="644" actId="1076"/>
+        <pc:sldMkLst>
+          <pc:docMk/>
+          <pc:sldMk cId="2075073051" sldId="315"/>
+        </pc:sldMkLst>
+        <pc:picChg chg="add mod">
+          <ac:chgData name="Norbey Muñoz" userId="b7e811e8891ccd42" providerId="LiveId" clId="{2482167B-ADD3-4E68-AB8B-ADE9CECE27D0}" dt="2026-06-10T03:31:27.404" v="644" actId="1076"/>
+          <ac:picMkLst>
+            <pc:docMk/>
+            <pc:sldMk cId="2075073051" sldId="315"/>
+            <ac:picMk id="2" creationId="{D90BAE3B-A816-7A5A-FDF0-801F4BB23ECE}"/>
+          </ac:picMkLst>
+        </pc:picChg>
+        <pc:picChg chg="del">
+          <ac:chgData name="Norbey Muñoz" userId="b7e811e8891ccd42" providerId="LiveId" clId="{2482167B-ADD3-4E68-AB8B-ADE9CECE27D0}" dt="2026-06-10T03:31:20.861" v="641" actId="478"/>
+          <ac:picMkLst>
+            <pc:docMk/>
+            <pc:sldMk cId="2075073051" sldId="315"/>
+            <ac:picMk id="3" creationId="{5243205F-4513-A6D0-9792-84B5CD94F1E7}"/>
+          </ac:picMkLst>
+        </pc:picChg>
+      </pc:sldChg>
+      <pc:sldChg chg="add">
+        <pc:chgData name="Norbey Muñoz" userId="b7e811e8891ccd42" providerId="LiveId" clId="{2482167B-ADD3-4E68-AB8B-ADE9CECE27D0}" dt="2026-06-10T03:31:48.621" v="645" actId="2890"/>
+        <pc:sldMkLst>
+          <pc:docMk/>
+          <pc:sldMk cId="3666961221" sldId="316"/>
+        </pc:sldMkLst>
+      </pc:sldChg>
+      <pc:sldChg chg="addSp delSp modSp add mod ord">
+        <pc:chgData name="Norbey Muñoz" userId="b7e811e8891ccd42" providerId="LiveId" clId="{2482167B-ADD3-4E68-AB8B-ADE9CECE27D0}" dt="2026-06-10T03:33:25.530" v="661"/>
+        <pc:sldMkLst>
+          <pc:docMk/>
+          <pc:sldMk cId="3521252694" sldId="317"/>
+        </pc:sldMkLst>
+        <pc:picChg chg="del">
+          <ac:chgData name="Norbey Muñoz" userId="b7e811e8891ccd42" providerId="LiveId" clId="{2482167B-ADD3-4E68-AB8B-ADE9CECE27D0}" dt="2026-06-10T03:33:01.308" v="653" actId="478"/>
+          <ac:picMkLst>
+            <pc:docMk/>
+            <pc:sldMk cId="3521252694" sldId="317"/>
+            <ac:picMk id="2" creationId="{B0051076-2234-8AD6-AB25-028593083F16}"/>
+          </ac:picMkLst>
+        </pc:picChg>
+        <pc:picChg chg="add mod">
+          <ac:chgData name="Norbey Muñoz" userId="b7e811e8891ccd42" providerId="LiveId" clId="{2482167B-ADD3-4E68-AB8B-ADE9CECE27D0}" dt="2026-06-10T03:33:13.015" v="659" actId="1076"/>
+          <ac:picMkLst>
+            <pc:docMk/>
+            <pc:sldMk cId="3521252694" sldId="317"/>
+            <ac:picMk id="3" creationId="{4DBD2545-18F6-E74C-E43A-D17EFF0CAD5D}"/>
           </ac:picMkLst>
         </pc:picChg>
       </pc:sldChg>
@@ -1642,7 +1633,7 @@
               <a:pPr>
                 <a:defRPr/>
               </a:pPr>
-              <a:t>‹Nº›</a:t>
+              <a:t>‹#›</a:t>
             </a:fld>
             <a:endParaRPr lang="es-ES" altLang="en-US"/>
           </a:p>
@@ -10579,7 +10570,7 @@
         <p:cNvPr id="1" name="">
           <a:extLst>
             <a:ext uri="{FF2B5EF4-FFF2-40B4-BE49-F238E27FC236}">
-              <a16:creationId xmlns:a16="http://schemas.microsoft.com/office/drawing/2014/main" id="{96438B52-265F-B057-99E3-BDD69A41C68D}"/>
+              <a16:creationId xmlns:a16="http://schemas.microsoft.com/office/drawing/2014/main" id="{7EBED06F-A302-1AF6-EAA3-E18352BA6FEB}"/>
             </a:ext>
           </a:extLst>
         </p:cNvPr>
@@ -10599,7 +10590,7 @@
           <p:cNvPr id="9218" name="Rectangle 7">
             <a:extLst>
               <a:ext uri="{FF2B5EF4-FFF2-40B4-BE49-F238E27FC236}">
-                <a16:creationId xmlns:a16="http://schemas.microsoft.com/office/drawing/2014/main" id="{D9641625-13FB-BA15-F4C0-7AE3FDD2C098}"/>
+                <a16:creationId xmlns:a16="http://schemas.microsoft.com/office/drawing/2014/main" id="{D243A519-26C1-80DF-227D-519964A5A2A4}"/>
               </a:ext>
             </a:extLst>
           </p:cNvPr>
@@ -10780,7 +10771,7 @@
           <p:cNvPr id="9219" name="Rectangle 2">
             <a:extLst>
               <a:ext uri="{FF2B5EF4-FFF2-40B4-BE49-F238E27FC236}">
-                <a16:creationId xmlns:a16="http://schemas.microsoft.com/office/drawing/2014/main" id="{EC09BB21-23D1-1DC7-2ABD-440E0B39E565}"/>
+                <a16:creationId xmlns:a16="http://schemas.microsoft.com/office/drawing/2014/main" id="{AF5A1A83-4A21-CB6B-2522-BD1BCCC004E3}"/>
               </a:ext>
             </a:extLst>
           </p:cNvPr>
@@ -10800,7 +10791,7 @@
           <p:cNvPr id="9220" name="Rectangle 3">
             <a:extLst>
               <a:ext uri="{FF2B5EF4-FFF2-40B4-BE49-F238E27FC236}">
-                <a16:creationId xmlns:a16="http://schemas.microsoft.com/office/drawing/2014/main" id="{E384E863-A48C-0D57-351D-BDD1CB260A28}"/>
+                <a16:creationId xmlns:a16="http://schemas.microsoft.com/office/drawing/2014/main" id="{B4DB5C5E-0296-DB1E-319B-B3FB4323D121}"/>
               </a:ext>
             </a:extLst>
           </p:cNvPr>
@@ -10856,7 +10847,7 @@
     </p:spTree>
     <p:extLst>
       <p:ext uri="{BB962C8B-B14F-4D97-AF65-F5344CB8AC3E}">
-        <p14:creationId xmlns:p14="http://schemas.microsoft.com/office/powerpoint/2010/main" val="2905966659"/>
+        <p14:creationId xmlns:p14="http://schemas.microsoft.com/office/powerpoint/2010/main" val="2236394196"/>
       </p:ext>
     </p:extLst>
   </p:cSld>
@@ -10874,7 +10865,7 @@
         <p:cNvPr id="1" name="">
           <a:extLst>
             <a:ext uri="{FF2B5EF4-FFF2-40B4-BE49-F238E27FC236}">
-              <a16:creationId xmlns:a16="http://schemas.microsoft.com/office/drawing/2014/main" id="{8E1BE1C4-F1DF-9F09-03A7-D08A12A8C767}"/>
+              <a16:creationId xmlns:a16="http://schemas.microsoft.com/office/drawing/2014/main" id="{18FA1333-032D-1BC0-5AB2-5F1EFAFC9115}"/>
             </a:ext>
           </a:extLst>
         </p:cNvPr>
@@ -10891,10 +10882,10 @@
       </p:grpSpPr>
       <p:sp>
         <p:nvSpPr>
-          <p:cNvPr id="21506" name="Rectangle 7">
+          <p:cNvPr id="9218" name="Rectangle 7">
             <a:extLst>
               <a:ext uri="{FF2B5EF4-FFF2-40B4-BE49-F238E27FC236}">
-                <a16:creationId xmlns:a16="http://schemas.microsoft.com/office/drawing/2014/main" id="{B452A4C7-FC25-6F40-3999-54F32DBDD515}"/>
+                <a16:creationId xmlns:a16="http://schemas.microsoft.com/office/drawing/2014/main" id="{3A291171-5212-B896-9529-954626F66003}"/>
               </a:ext>
             </a:extLst>
           </p:cNvPr>
@@ -11057,7 +11048,7 @@
                 <a:spcPct val="0"/>
               </a:spcBef>
             </a:pPr>
-            <a:fld id="{2965FB0D-81DB-4A5B-A3ED-B3706CA0E5D3}" type="slidenum">
+            <a:fld id="{66632F5B-0F93-462C-895D-634842356F5B}" type="slidenum">
               <a:rPr kumimoji="0" lang="es-ES" altLang="en-US"/>
               <a:pPr>
                 <a:spcBef>
@@ -11072,10 +11063,10 @@
       </p:sp>
       <p:sp>
         <p:nvSpPr>
-          <p:cNvPr id="21507" name="Rectangle 2">
+          <p:cNvPr id="9219" name="Rectangle 2">
             <a:extLst>
               <a:ext uri="{FF2B5EF4-FFF2-40B4-BE49-F238E27FC236}">
-                <a16:creationId xmlns:a16="http://schemas.microsoft.com/office/drawing/2014/main" id="{A12BF216-6A1B-6F88-7EFA-B0E5A047A999}"/>
+                <a16:creationId xmlns:a16="http://schemas.microsoft.com/office/drawing/2014/main" id="{B4B97FD4-B610-526D-04CE-68543D3D528F}"/>
               </a:ext>
             </a:extLst>
           </p:cNvPr>
@@ -11092,10 +11083,10 @@
       </p:sp>
       <p:sp>
         <p:nvSpPr>
-          <p:cNvPr id="21508" name="Rectangle 3">
+          <p:cNvPr id="9220" name="Rectangle 3">
             <a:extLst>
               <a:ext uri="{FF2B5EF4-FFF2-40B4-BE49-F238E27FC236}">
-                <a16:creationId xmlns:a16="http://schemas.microsoft.com/office/drawing/2014/main" id="{0032BB52-A9F0-FC93-C25C-54B3AB5F3218}"/>
+                <a16:creationId xmlns:a16="http://schemas.microsoft.com/office/drawing/2014/main" id="{699537E9-AAC6-0DA7-EF11-E4EF0C55440A}"/>
               </a:ext>
             </a:extLst>
           </p:cNvPr>
@@ -11151,7 +11142,7 @@
     </p:spTree>
     <p:extLst>
       <p:ext uri="{BB962C8B-B14F-4D97-AF65-F5344CB8AC3E}">
-        <p14:creationId xmlns:p14="http://schemas.microsoft.com/office/powerpoint/2010/main" val="3177508128"/>
+        <p14:creationId xmlns:p14="http://schemas.microsoft.com/office/powerpoint/2010/main" val="3042667251"/>
       </p:ext>
     </p:extLst>
   </p:cSld>
@@ -11166,7 +11157,13 @@
   <p:cSld>
     <p:spTree>
       <p:nvGrpSpPr>
-        <p:cNvPr id="1" name=""/>
+        <p:cNvPr id="1" name="">
+          <a:extLst>
+            <a:ext uri="{FF2B5EF4-FFF2-40B4-BE49-F238E27FC236}">
+              <a16:creationId xmlns:a16="http://schemas.microsoft.com/office/drawing/2014/main" id="{E6F24C4A-1C44-7E41-58AC-CCCBEA160F3C}"/>
+            </a:ext>
+          </a:extLst>
+        </p:cNvPr>
         <p:cNvGrpSpPr/>
         <p:nvPr/>
       </p:nvGrpSpPr>
@@ -11180,10 +11177,10 @@
       </p:grpSpPr>
       <p:sp>
         <p:nvSpPr>
-          <p:cNvPr id="23554" name="Rectangle 7">
+          <p:cNvPr id="9218" name="Rectangle 7">
             <a:extLst>
               <a:ext uri="{FF2B5EF4-FFF2-40B4-BE49-F238E27FC236}">
-                <a16:creationId xmlns:a16="http://schemas.microsoft.com/office/drawing/2014/main" id="{86E7A627-DDD5-B676-907C-AA6C945090B7}"/>
+                <a16:creationId xmlns:a16="http://schemas.microsoft.com/office/drawing/2014/main" id="{1E68C21D-B531-F653-4A10-E5AC74482C24}"/>
               </a:ext>
             </a:extLst>
           </p:cNvPr>
@@ -11346,7 +11343,7 @@
                 <a:spcPct val="0"/>
               </a:spcBef>
             </a:pPr>
-            <a:fld id="{C2D9BAF6-4B93-4EA6-A9A5-26CAE860A30B}" type="slidenum">
+            <a:fld id="{66632F5B-0F93-462C-895D-634842356F5B}" type="slidenum">
               <a:rPr kumimoji="0" lang="es-ES" altLang="en-US"/>
               <a:pPr>
                 <a:spcBef>
@@ -11361,10 +11358,10 @@
       </p:sp>
       <p:sp>
         <p:nvSpPr>
-          <p:cNvPr id="23555" name="Rectangle 2">
+          <p:cNvPr id="9219" name="Rectangle 2">
             <a:extLst>
               <a:ext uri="{FF2B5EF4-FFF2-40B4-BE49-F238E27FC236}">
-                <a16:creationId xmlns:a16="http://schemas.microsoft.com/office/drawing/2014/main" id="{8A9599AD-C52C-C1EA-E9D2-846998CB051F}"/>
+                <a16:creationId xmlns:a16="http://schemas.microsoft.com/office/drawing/2014/main" id="{CA991583-77F3-1A21-6C1D-68D2A16CD3D0}"/>
               </a:ext>
             </a:extLst>
           </p:cNvPr>
@@ -11381,10 +11378,10 @@
       </p:sp>
       <p:sp>
         <p:nvSpPr>
-          <p:cNvPr id="23556" name="Rectangle 3">
+          <p:cNvPr id="9220" name="Rectangle 3">
             <a:extLst>
               <a:ext uri="{FF2B5EF4-FFF2-40B4-BE49-F238E27FC236}">
-                <a16:creationId xmlns:a16="http://schemas.microsoft.com/office/drawing/2014/main" id="{CDA498A1-19D2-FB11-A95E-324A065D7BDF}"/>
+                <a16:creationId xmlns:a16="http://schemas.microsoft.com/office/drawing/2014/main" id="{E2FCEB46-D60C-79A8-FD31-A634C23A5EAE}"/>
               </a:ext>
             </a:extLst>
           </p:cNvPr>
@@ -11438,6 +11435,11 @@
         </p:txBody>
       </p:sp>
     </p:spTree>
+    <p:extLst>
+      <p:ext uri="{BB962C8B-B14F-4D97-AF65-F5344CB8AC3E}">
+        <p14:creationId xmlns:p14="http://schemas.microsoft.com/office/powerpoint/2010/main" val="1948150914"/>
+      </p:ext>
+    </p:extLst>
   </p:cSld>
   <p:clrMapOvr>
     <a:masterClrMapping/>
@@ -11745,6 +11747,1175 @@
   <p:cSld>
     <p:spTree>
       <p:nvGrpSpPr>
+        <p:cNvPr id="1" name="">
+          <a:extLst>
+            <a:ext uri="{FF2B5EF4-FFF2-40B4-BE49-F238E27FC236}">
+              <a16:creationId xmlns:a16="http://schemas.microsoft.com/office/drawing/2014/main" id="{EB025083-33E2-2A8B-5465-DDDC391E70C0}"/>
+            </a:ext>
+          </a:extLst>
+        </p:cNvPr>
+        <p:cNvGrpSpPr/>
+        <p:nvPr/>
+      </p:nvGrpSpPr>
+      <p:grpSpPr>
+        <a:xfrm>
+          <a:off x="0" y="0"/>
+          <a:ext cx="0" cy="0"/>
+          <a:chOff x="0" y="0"/>
+          <a:chExt cx="0" cy="0"/>
+        </a:xfrm>
+      </p:grpSpPr>
+      <p:sp>
+        <p:nvSpPr>
+          <p:cNvPr id="9218" name="Rectangle 7">
+            <a:extLst>
+              <a:ext uri="{FF2B5EF4-FFF2-40B4-BE49-F238E27FC236}">
+                <a16:creationId xmlns:a16="http://schemas.microsoft.com/office/drawing/2014/main" id="{1CE9B308-BCE2-952A-F9CD-5E6833FFA436}"/>
+              </a:ext>
+            </a:extLst>
+          </p:cNvPr>
+          <p:cNvSpPr>
+            <a:spLocks noGrp="1" noChangeArrowheads="1"/>
+          </p:cNvSpPr>
+          <p:nvPr>
+            <p:ph type="sldNum" sz="quarter" idx="5"/>
+          </p:nvPr>
+        </p:nvSpPr>
+        <p:spPr>
+          <a:noFill/>
+          <a:extLst>
+            <a:ext uri="{909E8E84-426E-40DD-AFC4-6F175D3DCCD1}">
+              <a14:hiddenFill xmlns:a14="http://schemas.microsoft.com/office/drawing/2010/main">
+                <a:solidFill>
+                  <a:schemeClr val="accent1"/>
+                </a:solidFill>
+              </a14:hiddenFill>
+            </a:ext>
+            <a:ext uri="{91240B29-F687-4F45-9708-019B960494DF}">
+              <a14:hiddenLine xmlns:a14="http://schemas.microsoft.com/office/drawing/2010/main" w="9525">
+                <a:solidFill>
+                  <a:schemeClr val="tx1"/>
+                </a:solidFill>
+                <a:miter lim="800000"/>
+                <a:headEnd/>
+                <a:tailEnd/>
+              </a14:hiddenLine>
+            </a:ext>
+            <a:ext uri="{AF507438-7753-43E0-B8FC-AC1667EBCBE1}">
+              <a14:hiddenEffects xmlns:a14="http://schemas.microsoft.com/office/drawing/2010/main">
+                <a:effectLst>
+                  <a:outerShdw dist="35921" dir="2700000" algn="ctr" rotWithShape="0">
+                    <a:schemeClr val="bg2"/>
+                  </a:outerShdw>
+                </a:effectLst>
+              </a14:hiddenEffects>
+            </a:ext>
+          </a:extLst>
+        </p:spPr>
+        <p:txBody>
+          <a:bodyPr/>
+          <a:lstStyle>
+            <a:lvl1pPr>
+              <a:spcBef>
+                <a:spcPct val="30000"/>
+              </a:spcBef>
+              <a:defRPr kumimoji="1" sz="1200">
+                <a:solidFill>
+                  <a:schemeClr val="tx1"/>
+                </a:solidFill>
+                <a:latin typeface="Arial" panose="020B0604020202020204" pitchFamily="34" charset="0"/>
+              </a:defRPr>
+            </a:lvl1pPr>
+            <a:lvl2pPr marL="742950" indent="-285750">
+              <a:spcBef>
+                <a:spcPct val="30000"/>
+              </a:spcBef>
+              <a:defRPr kumimoji="1" sz="1200">
+                <a:solidFill>
+                  <a:schemeClr val="tx1"/>
+                </a:solidFill>
+                <a:latin typeface="Arial" panose="020B0604020202020204" pitchFamily="34" charset="0"/>
+              </a:defRPr>
+            </a:lvl2pPr>
+            <a:lvl3pPr marL="1143000" indent="-228600">
+              <a:spcBef>
+                <a:spcPct val="30000"/>
+              </a:spcBef>
+              <a:defRPr kumimoji="1" sz="1200">
+                <a:solidFill>
+                  <a:schemeClr val="tx1"/>
+                </a:solidFill>
+                <a:latin typeface="Arial" panose="020B0604020202020204" pitchFamily="34" charset="0"/>
+              </a:defRPr>
+            </a:lvl3pPr>
+            <a:lvl4pPr marL="1600200" indent="-228600">
+              <a:spcBef>
+                <a:spcPct val="30000"/>
+              </a:spcBef>
+              <a:defRPr kumimoji="1" sz="1200">
+                <a:solidFill>
+                  <a:schemeClr val="tx1"/>
+                </a:solidFill>
+                <a:latin typeface="Arial" panose="020B0604020202020204" pitchFamily="34" charset="0"/>
+              </a:defRPr>
+            </a:lvl4pPr>
+            <a:lvl5pPr marL="2057400" indent="-228600">
+              <a:spcBef>
+                <a:spcPct val="30000"/>
+              </a:spcBef>
+              <a:defRPr kumimoji="1" sz="1200">
+                <a:solidFill>
+                  <a:schemeClr val="tx1"/>
+                </a:solidFill>
+                <a:latin typeface="Arial" panose="020B0604020202020204" pitchFamily="34" charset="0"/>
+              </a:defRPr>
+            </a:lvl5pPr>
+            <a:lvl6pPr marL="2514600" indent="-228600" eaLnBrk="0" fontAlgn="base" hangingPunct="0">
+              <a:spcBef>
+                <a:spcPct val="30000"/>
+              </a:spcBef>
+              <a:spcAft>
+                <a:spcPct val="0"/>
+              </a:spcAft>
+              <a:defRPr kumimoji="1" sz="1200">
+                <a:solidFill>
+                  <a:schemeClr val="tx1"/>
+                </a:solidFill>
+                <a:latin typeface="Arial" panose="020B0604020202020204" pitchFamily="34" charset="0"/>
+              </a:defRPr>
+            </a:lvl6pPr>
+            <a:lvl7pPr marL="2971800" indent="-228600" eaLnBrk="0" fontAlgn="base" hangingPunct="0">
+              <a:spcBef>
+                <a:spcPct val="30000"/>
+              </a:spcBef>
+              <a:spcAft>
+                <a:spcPct val="0"/>
+              </a:spcAft>
+              <a:defRPr kumimoji="1" sz="1200">
+                <a:solidFill>
+                  <a:schemeClr val="tx1"/>
+                </a:solidFill>
+                <a:latin typeface="Arial" panose="020B0604020202020204" pitchFamily="34" charset="0"/>
+              </a:defRPr>
+            </a:lvl7pPr>
+            <a:lvl8pPr marL="3429000" indent="-228600" eaLnBrk="0" fontAlgn="base" hangingPunct="0">
+              <a:spcBef>
+                <a:spcPct val="30000"/>
+              </a:spcBef>
+              <a:spcAft>
+                <a:spcPct val="0"/>
+              </a:spcAft>
+              <a:defRPr kumimoji="1" sz="1200">
+                <a:solidFill>
+                  <a:schemeClr val="tx1"/>
+                </a:solidFill>
+                <a:latin typeface="Arial" panose="020B0604020202020204" pitchFamily="34" charset="0"/>
+              </a:defRPr>
+            </a:lvl8pPr>
+            <a:lvl9pPr marL="3886200" indent="-228600" eaLnBrk="0" fontAlgn="base" hangingPunct="0">
+              <a:spcBef>
+                <a:spcPct val="30000"/>
+              </a:spcBef>
+              <a:spcAft>
+                <a:spcPct val="0"/>
+              </a:spcAft>
+              <a:defRPr kumimoji="1" sz="1200">
+                <a:solidFill>
+                  <a:schemeClr val="tx1"/>
+                </a:solidFill>
+                <a:latin typeface="Arial" panose="020B0604020202020204" pitchFamily="34" charset="0"/>
+              </a:defRPr>
+            </a:lvl9pPr>
+          </a:lstStyle>
+          <a:p>
+            <a:pPr>
+              <a:spcBef>
+                <a:spcPct val="0"/>
+              </a:spcBef>
+            </a:pPr>
+            <a:fld id="{66632F5B-0F93-462C-895D-634842356F5B}" type="slidenum">
+              <a:rPr kumimoji="0" lang="es-ES" altLang="en-US"/>
+              <a:pPr>
+                <a:spcBef>
+                  <a:spcPct val="0"/>
+                </a:spcBef>
+              </a:pPr>
+              <a:t>42</a:t>
+            </a:fld>
+            <a:endParaRPr kumimoji="0" lang="es-ES" altLang="en-US"/>
+          </a:p>
+        </p:txBody>
+      </p:sp>
+      <p:sp>
+        <p:nvSpPr>
+          <p:cNvPr id="9219" name="Rectangle 2">
+            <a:extLst>
+              <a:ext uri="{FF2B5EF4-FFF2-40B4-BE49-F238E27FC236}">
+                <a16:creationId xmlns:a16="http://schemas.microsoft.com/office/drawing/2014/main" id="{1D877E35-7680-4586-430B-5FB9E3434C15}"/>
+              </a:ext>
+            </a:extLst>
+          </p:cNvPr>
+          <p:cNvSpPr>
+            <a:spLocks noGrp="1" noRot="1" noChangeAspect="1" noChangeArrowheads="1" noTextEdit="1"/>
+          </p:cNvSpPr>
+          <p:nvPr>
+            <p:ph type="sldImg"/>
+          </p:nvPr>
+        </p:nvSpPr>
+        <p:spPr>
+          <a:ln/>
+        </p:spPr>
+      </p:sp>
+      <p:sp>
+        <p:nvSpPr>
+          <p:cNvPr id="9220" name="Rectangle 3">
+            <a:extLst>
+              <a:ext uri="{FF2B5EF4-FFF2-40B4-BE49-F238E27FC236}">
+                <a16:creationId xmlns:a16="http://schemas.microsoft.com/office/drawing/2014/main" id="{32D6BB56-AE06-0497-2B3B-FF3A618ACDAC}"/>
+              </a:ext>
+            </a:extLst>
+          </p:cNvPr>
+          <p:cNvSpPr>
+            <a:spLocks noGrp="1" noChangeArrowheads="1"/>
+          </p:cNvSpPr>
+          <p:nvPr>
+            <p:ph type="body" idx="1"/>
+          </p:nvPr>
+        </p:nvSpPr>
+        <p:spPr>
+          <a:noFill/>
+          <a:extLst>
+            <a:ext uri="{909E8E84-426E-40DD-AFC4-6F175D3DCCD1}">
+              <a14:hiddenFill xmlns:a14="http://schemas.microsoft.com/office/drawing/2010/main">
+                <a:solidFill>
+                  <a:schemeClr val="accent1"/>
+                </a:solidFill>
+              </a14:hiddenFill>
+            </a:ext>
+            <a:ext uri="{91240B29-F687-4F45-9708-019B960494DF}">
+              <a14:hiddenLine xmlns:a14="http://schemas.microsoft.com/office/drawing/2010/main" w="9525">
+                <a:solidFill>
+                  <a:schemeClr val="tx1"/>
+                </a:solidFill>
+                <a:miter lim="800000"/>
+                <a:headEnd/>
+                <a:tailEnd/>
+              </a14:hiddenLine>
+            </a:ext>
+            <a:ext uri="{AF507438-7753-43E0-B8FC-AC1667EBCBE1}">
+              <a14:hiddenEffects xmlns:a14="http://schemas.microsoft.com/office/drawing/2010/main">
+                <a:effectLst>
+                  <a:outerShdw dist="35921" dir="2700000" algn="ctr" rotWithShape="0">
+                    <a:schemeClr val="bg2"/>
+                  </a:outerShdw>
+                </a:effectLst>
+              </a14:hiddenEffects>
+            </a:ext>
+          </a:extLst>
+        </p:spPr>
+        <p:txBody>
+          <a:bodyPr/>
+          <a:lstStyle/>
+          <a:p>
+            <a:pPr eaLnBrk="1" hangingPunct="1"/>
+            <a:endParaRPr lang="es-ES" altLang="en-US">
+              <a:latin typeface="Arial" panose="020B0604020202020204" pitchFamily="34" charset="0"/>
+            </a:endParaRPr>
+          </a:p>
+        </p:txBody>
+      </p:sp>
+    </p:spTree>
+    <p:extLst>
+      <p:ext uri="{BB962C8B-B14F-4D97-AF65-F5344CB8AC3E}">
+        <p14:creationId xmlns:p14="http://schemas.microsoft.com/office/powerpoint/2010/main" val="2321347165"/>
+      </p:ext>
+    </p:extLst>
+  </p:cSld>
+  <p:clrMapOvr>
+    <a:masterClrMapping/>
+  </p:clrMapOvr>
+</p:notes>
+</file>
+
+<file path=ppt/notesSlides/notesSlide41.xml><?xml version="1.0" encoding="utf-8"?>
+<p:notes xmlns:a="http://schemas.openxmlformats.org/drawingml/2006/main" xmlns:r="http://schemas.openxmlformats.org/officeDocument/2006/relationships" xmlns:p="http://schemas.openxmlformats.org/presentationml/2006/main">
+  <p:cSld>
+    <p:spTree>
+      <p:nvGrpSpPr>
+        <p:cNvPr id="1" name="">
+          <a:extLst>
+            <a:ext uri="{FF2B5EF4-FFF2-40B4-BE49-F238E27FC236}">
+              <a16:creationId xmlns:a16="http://schemas.microsoft.com/office/drawing/2014/main" id="{96438B52-265F-B057-99E3-BDD69A41C68D}"/>
+            </a:ext>
+          </a:extLst>
+        </p:cNvPr>
+        <p:cNvGrpSpPr/>
+        <p:nvPr/>
+      </p:nvGrpSpPr>
+      <p:grpSpPr>
+        <a:xfrm>
+          <a:off x="0" y="0"/>
+          <a:ext cx="0" cy="0"/>
+          <a:chOff x="0" y="0"/>
+          <a:chExt cx="0" cy="0"/>
+        </a:xfrm>
+      </p:grpSpPr>
+      <p:sp>
+        <p:nvSpPr>
+          <p:cNvPr id="9218" name="Rectangle 7">
+            <a:extLst>
+              <a:ext uri="{FF2B5EF4-FFF2-40B4-BE49-F238E27FC236}">
+                <a16:creationId xmlns:a16="http://schemas.microsoft.com/office/drawing/2014/main" id="{D9641625-13FB-BA15-F4C0-7AE3FDD2C098}"/>
+              </a:ext>
+            </a:extLst>
+          </p:cNvPr>
+          <p:cNvSpPr>
+            <a:spLocks noGrp="1" noChangeArrowheads="1"/>
+          </p:cNvSpPr>
+          <p:nvPr>
+            <p:ph type="sldNum" sz="quarter" idx="5"/>
+          </p:nvPr>
+        </p:nvSpPr>
+        <p:spPr>
+          <a:noFill/>
+          <a:extLst>
+            <a:ext uri="{909E8E84-426E-40DD-AFC4-6F175D3DCCD1}">
+              <a14:hiddenFill xmlns:a14="http://schemas.microsoft.com/office/drawing/2010/main">
+                <a:solidFill>
+                  <a:schemeClr val="accent1"/>
+                </a:solidFill>
+              </a14:hiddenFill>
+            </a:ext>
+            <a:ext uri="{91240B29-F687-4F45-9708-019B960494DF}">
+              <a14:hiddenLine xmlns:a14="http://schemas.microsoft.com/office/drawing/2010/main" w="9525">
+                <a:solidFill>
+                  <a:schemeClr val="tx1"/>
+                </a:solidFill>
+                <a:miter lim="800000"/>
+                <a:headEnd/>
+                <a:tailEnd/>
+              </a14:hiddenLine>
+            </a:ext>
+            <a:ext uri="{AF507438-7753-43E0-B8FC-AC1667EBCBE1}">
+              <a14:hiddenEffects xmlns:a14="http://schemas.microsoft.com/office/drawing/2010/main">
+                <a:effectLst>
+                  <a:outerShdw dist="35921" dir="2700000" algn="ctr" rotWithShape="0">
+                    <a:schemeClr val="bg2"/>
+                  </a:outerShdw>
+                </a:effectLst>
+              </a14:hiddenEffects>
+            </a:ext>
+          </a:extLst>
+        </p:spPr>
+        <p:txBody>
+          <a:bodyPr/>
+          <a:lstStyle>
+            <a:lvl1pPr>
+              <a:spcBef>
+                <a:spcPct val="30000"/>
+              </a:spcBef>
+              <a:defRPr kumimoji="1" sz="1200">
+                <a:solidFill>
+                  <a:schemeClr val="tx1"/>
+                </a:solidFill>
+                <a:latin typeface="Arial" panose="020B0604020202020204" pitchFamily="34" charset="0"/>
+              </a:defRPr>
+            </a:lvl1pPr>
+            <a:lvl2pPr marL="742950" indent="-285750">
+              <a:spcBef>
+                <a:spcPct val="30000"/>
+              </a:spcBef>
+              <a:defRPr kumimoji="1" sz="1200">
+                <a:solidFill>
+                  <a:schemeClr val="tx1"/>
+                </a:solidFill>
+                <a:latin typeface="Arial" panose="020B0604020202020204" pitchFamily="34" charset="0"/>
+              </a:defRPr>
+            </a:lvl2pPr>
+            <a:lvl3pPr marL="1143000" indent="-228600">
+              <a:spcBef>
+                <a:spcPct val="30000"/>
+              </a:spcBef>
+              <a:defRPr kumimoji="1" sz="1200">
+                <a:solidFill>
+                  <a:schemeClr val="tx1"/>
+                </a:solidFill>
+                <a:latin typeface="Arial" panose="020B0604020202020204" pitchFamily="34" charset="0"/>
+              </a:defRPr>
+            </a:lvl3pPr>
+            <a:lvl4pPr marL="1600200" indent="-228600">
+              <a:spcBef>
+                <a:spcPct val="30000"/>
+              </a:spcBef>
+              <a:defRPr kumimoji="1" sz="1200">
+                <a:solidFill>
+                  <a:schemeClr val="tx1"/>
+                </a:solidFill>
+                <a:latin typeface="Arial" panose="020B0604020202020204" pitchFamily="34" charset="0"/>
+              </a:defRPr>
+            </a:lvl4pPr>
+            <a:lvl5pPr marL="2057400" indent="-228600">
+              <a:spcBef>
+                <a:spcPct val="30000"/>
+              </a:spcBef>
+              <a:defRPr kumimoji="1" sz="1200">
+                <a:solidFill>
+                  <a:schemeClr val="tx1"/>
+                </a:solidFill>
+                <a:latin typeface="Arial" panose="020B0604020202020204" pitchFamily="34" charset="0"/>
+              </a:defRPr>
+            </a:lvl5pPr>
+            <a:lvl6pPr marL="2514600" indent="-228600" eaLnBrk="0" fontAlgn="base" hangingPunct="0">
+              <a:spcBef>
+                <a:spcPct val="30000"/>
+              </a:spcBef>
+              <a:spcAft>
+                <a:spcPct val="0"/>
+              </a:spcAft>
+              <a:defRPr kumimoji="1" sz="1200">
+                <a:solidFill>
+                  <a:schemeClr val="tx1"/>
+                </a:solidFill>
+                <a:latin typeface="Arial" panose="020B0604020202020204" pitchFamily="34" charset="0"/>
+              </a:defRPr>
+            </a:lvl6pPr>
+            <a:lvl7pPr marL="2971800" indent="-228600" eaLnBrk="0" fontAlgn="base" hangingPunct="0">
+              <a:spcBef>
+                <a:spcPct val="30000"/>
+              </a:spcBef>
+              <a:spcAft>
+                <a:spcPct val="0"/>
+              </a:spcAft>
+              <a:defRPr kumimoji="1" sz="1200">
+                <a:solidFill>
+                  <a:schemeClr val="tx1"/>
+                </a:solidFill>
+                <a:latin typeface="Arial" panose="020B0604020202020204" pitchFamily="34" charset="0"/>
+              </a:defRPr>
+            </a:lvl7pPr>
+            <a:lvl8pPr marL="3429000" indent="-228600" eaLnBrk="0" fontAlgn="base" hangingPunct="0">
+              <a:spcBef>
+                <a:spcPct val="30000"/>
+              </a:spcBef>
+              <a:spcAft>
+                <a:spcPct val="0"/>
+              </a:spcAft>
+              <a:defRPr kumimoji="1" sz="1200">
+                <a:solidFill>
+                  <a:schemeClr val="tx1"/>
+                </a:solidFill>
+                <a:latin typeface="Arial" panose="020B0604020202020204" pitchFamily="34" charset="0"/>
+              </a:defRPr>
+            </a:lvl8pPr>
+            <a:lvl9pPr marL="3886200" indent="-228600" eaLnBrk="0" fontAlgn="base" hangingPunct="0">
+              <a:spcBef>
+                <a:spcPct val="30000"/>
+              </a:spcBef>
+              <a:spcAft>
+                <a:spcPct val="0"/>
+              </a:spcAft>
+              <a:defRPr kumimoji="1" sz="1200">
+                <a:solidFill>
+                  <a:schemeClr val="tx1"/>
+                </a:solidFill>
+                <a:latin typeface="Arial" panose="020B0604020202020204" pitchFamily="34" charset="0"/>
+              </a:defRPr>
+            </a:lvl9pPr>
+          </a:lstStyle>
+          <a:p>
+            <a:pPr>
+              <a:spcBef>
+                <a:spcPct val="0"/>
+              </a:spcBef>
+            </a:pPr>
+            <a:fld id="{66632F5B-0F93-462C-895D-634842356F5B}" type="slidenum">
+              <a:rPr kumimoji="0" lang="es-ES" altLang="en-US"/>
+              <a:pPr>
+                <a:spcBef>
+                  <a:spcPct val="0"/>
+                </a:spcBef>
+              </a:pPr>
+              <a:t>43</a:t>
+            </a:fld>
+            <a:endParaRPr kumimoji="0" lang="es-ES" altLang="en-US"/>
+          </a:p>
+        </p:txBody>
+      </p:sp>
+      <p:sp>
+        <p:nvSpPr>
+          <p:cNvPr id="9219" name="Rectangle 2">
+            <a:extLst>
+              <a:ext uri="{FF2B5EF4-FFF2-40B4-BE49-F238E27FC236}">
+                <a16:creationId xmlns:a16="http://schemas.microsoft.com/office/drawing/2014/main" id="{EC09BB21-23D1-1DC7-2ABD-440E0B39E565}"/>
+              </a:ext>
+            </a:extLst>
+          </p:cNvPr>
+          <p:cNvSpPr>
+            <a:spLocks noGrp="1" noRot="1" noChangeAspect="1" noChangeArrowheads="1" noTextEdit="1"/>
+          </p:cNvSpPr>
+          <p:nvPr>
+            <p:ph type="sldImg"/>
+          </p:nvPr>
+        </p:nvSpPr>
+        <p:spPr>
+          <a:ln/>
+        </p:spPr>
+      </p:sp>
+      <p:sp>
+        <p:nvSpPr>
+          <p:cNvPr id="9220" name="Rectangle 3">
+            <a:extLst>
+              <a:ext uri="{FF2B5EF4-FFF2-40B4-BE49-F238E27FC236}">
+                <a16:creationId xmlns:a16="http://schemas.microsoft.com/office/drawing/2014/main" id="{E384E863-A48C-0D57-351D-BDD1CB260A28}"/>
+              </a:ext>
+            </a:extLst>
+          </p:cNvPr>
+          <p:cNvSpPr>
+            <a:spLocks noGrp="1" noChangeArrowheads="1"/>
+          </p:cNvSpPr>
+          <p:nvPr>
+            <p:ph type="body" idx="1"/>
+          </p:nvPr>
+        </p:nvSpPr>
+        <p:spPr>
+          <a:noFill/>
+          <a:extLst>
+            <a:ext uri="{909E8E84-426E-40DD-AFC4-6F175D3DCCD1}">
+              <a14:hiddenFill xmlns:a14="http://schemas.microsoft.com/office/drawing/2010/main">
+                <a:solidFill>
+                  <a:schemeClr val="accent1"/>
+                </a:solidFill>
+              </a14:hiddenFill>
+            </a:ext>
+            <a:ext uri="{91240B29-F687-4F45-9708-019B960494DF}">
+              <a14:hiddenLine xmlns:a14="http://schemas.microsoft.com/office/drawing/2010/main" w="9525">
+                <a:solidFill>
+                  <a:schemeClr val="tx1"/>
+                </a:solidFill>
+                <a:miter lim="800000"/>
+                <a:headEnd/>
+                <a:tailEnd/>
+              </a14:hiddenLine>
+            </a:ext>
+            <a:ext uri="{AF507438-7753-43E0-B8FC-AC1667EBCBE1}">
+              <a14:hiddenEffects xmlns:a14="http://schemas.microsoft.com/office/drawing/2010/main">
+                <a:effectLst>
+                  <a:outerShdw dist="35921" dir="2700000" algn="ctr" rotWithShape="0">
+                    <a:schemeClr val="bg2"/>
+                  </a:outerShdw>
+                </a:effectLst>
+              </a14:hiddenEffects>
+            </a:ext>
+          </a:extLst>
+        </p:spPr>
+        <p:txBody>
+          <a:bodyPr/>
+          <a:lstStyle/>
+          <a:p>
+            <a:pPr eaLnBrk="1" hangingPunct="1"/>
+            <a:endParaRPr lang="es-ES" altLang="en-US">
+              <a:latin typeface="Arial" panose="020B0604020202020204" pitchFamily="34" charset="0"/>
+            </a:endParaRPr>
+          </a:p>
+        </p:txBody>
+      </p:sp>
+    </p:spTree>
+    <p:extLst>
+      <p:ext uri="{BB962C8B-B14F-4D97-AF65-F5344CB8AC3E}">
+        <p14:creationId xmlns:p14="http://schemas.microsoft.com/office/powerpoint/2010/main" val="2905966659"/>
+      </p:ext>
+    </p:extLst>
+  </p:cSld>
+  <p:clrMapOvr>
+    <a:masterClrMapping/>
+  </p:clrMapOvr>
+</p:notes>
+</file>
+
+<file path=ppt/notesSlides/notesSlide42.xml><?xml version="1.0" encoding="utf-8"?>
+<p:notes xmlns:a="http://schemas.openxmlformats.org/drawingml/2006/main" xmlns:r="http://schemas.openxmlformats.org/officeDocument/2006/relationships" xmlns:p="http://schemas.openxmlformats.org/presentationml/2006/main">
+  <p:cSld>
+    <p:spTree>
+      <p:nvGrpSpPr>
+        <p:cNvPr id="1" name="">
+          <a:extLst>
+            <a:ext uri="{FF2B5EF4-FFF2-40B4-BE49-F238E27FC236}">
+              <a16:creationId xmlns:a16="http://schemas.microsoft.com/office/drawing/2014/main" id="{8E1BE1C4-F1DF-9F09-03A7-D08A12A8C767}"/>
+            </a:ext>
+          </a:extLst>
+        </p:cNvPr>
+        <p:cNvGrpSpPr/>
+        <p:nvPr/>
+      </p:nvGrpSpPr>
+      <p:grpSpPr>
+        <a:xfrm>
+          <a:off x="0" y="0"/>
+          <a:ext cx="0" cy="0"/>
+          <a:chOff x="0" y="0"/>
+          <a:chExt cx="0" cy="0"/>
+        </a:xfrm>
+      </p:grpSpPr>
+      <p:sp>
+        <p:nvSpPr>
+          <p:cNvPr id="21506" name="Rectangle 7">
+            <a:extLst>
+              <a:ext uri="{FF2B5EF4-FFF2-40B4-BE49-F238E27FC236}">
+                <a16:creationId xmlns:a16="http://schemas.microsoft.com/office/drawing/2014/main" id="{B452A4C7-FC25-6F40-3999-54F32DBDD515}"/>
+              </a:ext>
+            </a:extLst>
+          </p:cNvPr>
+          <p:cNvSpPr>
+            <a:spLocks noGrp="1" noChangeArrowheads="1"/>
+          </p:cNvSpPr>
+          <p:nvPr>
+            <p:ph type="sldNum" sz="quarter" idx="5"/>
+          </p:nvPr>
+        </p:nvSpPr>
+        <p:spPr>
+          <a:noFill/>
+          <a:extLst>
+            <a:ext uri="{909E8E84-426E-40DD-AFC4-6F175D3DCCD1}">
+              <a14:hiddenFill xmlns:a14="http://schemas.microsoft.com/office/drawing/2010/main">
+                <a:solidFill>
+                  <a:schemeClr val="accent1"/>
+                </a:solidFill>
+              </a14:hiddenFill>
+            </a:ext>
+            <a:ext uri="{91240B29-F687-4F45-9708-019B960494DF}">
+              <a14:hiddenLine xmlns:a14="http://schemas.microsoft.com/office/drawing/2010/main" w="9525">
+                <a:solidFill>
+                  <a:schemeClr val="tx1"/>
+                </a:solidFill>
+                <a:miter lim="800000"/>
+                <a:headEnd/>
+                <a:tailEnd/>
+              </a14:hiddenLine>
+            </a:ext>
+            <a:ext uri="{AF507438-7753-43E0-B8FC-AC1667EBCBE1}">
+              <a14:hiddenEffects xmlns:a14="http://schemas.microsoft.com/office/drawing/2010/main">
+                <a:effectLst>
+                  <a:outerShdw dist="35921" dir="2700000" algn="ctr" rotWithShape="0">
+                    <a:schemeClr val="bg2"/>
+                  </a:outerShdw>
+                </a:effectLst>
+              </a14:hiddenEffects>
+            </a:ext>
+          </a:extLst>
+        </p:spPr>
+        <p:txBody>
+          <a:bodyPr/>
+          <a:lstStyle>
+            <a:lvl1pPr>
+              <a:spcBef>
+                <a:spcPct val="30000"/>
+              </a:spcBef>
+              <a:defRPr kumimoji="1" sz="1200">
+                <a:solidFill>
+                  <a:schemeClr val="tx1"/>
+                </a:solidFill>
+                <a:latin typeface="Arial" panose="020B0604020202020204" pitchFamily="34" charset="0"/>
+              </a:defRPr>
+            </a:lvl1pPr>
+            <a:lvl2pPr marL="742950" indent="-285750">
+              <a:spcBef>
+                <a:spcPct val="30000"/>
+              </a:spcBef>
+              <a:defRPr kumimoji="1" sz="1200">
+                <a:solidFill>
+                  <a:schemeClr val="tx1"/>
+                </a:solidFill>
+                <a:latin typeface="Arial" panose="020B0604020202020204" pitchFamily="34" charset="0"/>
+              </a:defRPr>
+            </a:lvl2pPr>
+            <a:lvl3pPr marL="1143000" indent="-228600">
+              <a:spcBef>
+                <a:spcPct val="30000"/>
+              </a:spcBef>
+              <a:defRPr kumimoji="1" sz="1200">
+                <a:solidFill>
+                  <a:schemeClr val="tx1"/>
+                </a:solidFill>
+                <a:latin typeface="Arial" panose="020B0604020202020204" pitchFamily="34" charset="0"/>
+              </a:defRPr>
+            </a:lvl3pPr>
+            <a:lvl4pPr marL="1600200" indent="-228600">
+              <a:spcBef>
+                <a:spcPct val="30000"/>
+              </a:spcBef>
+              <a:defRPr kumimoji="1" sz="1200">
+                <a:solidFill>
+                  <a:schemeClr val="tx1"/>
+                </a:solidFill>
+                <a:latin typeface="Arial" panose="020B0604020202020204" pitchFamily="34" charset="0"/>
+              </a:defRPr>
+            </a:lvl4pPr>
+            <a:lvl5pPr marL="2057400" indent="-228600">
+              <a:spcBef>
+                <a:spcPct val="30000"/>
+              </a:spcBef>
+              <a:defRPr kumimoji="1" sz="1200">
+                <a:solidFill>
+                  <a:schemeClr val="tx1"/>
+                </a:solidFill>
+                <a:latin typeface="Arial" panose="020B0604020202020204" pitchFamily="34" charset="0"/>
+              </a:defRPr>
+            </a:lvl5pPr>
+            <a:lvl6pPr marL="2514600" indent="-228600" eaLnBrk="0" fontAlgn="base" hangingPunct="0">
+              <a:spcBef>
+                <a:spcPct val="30000"/>
+              </a:spcBef>
+              <a:spcAft>
+                <a:spcPct val="0"/>
+              </a:spcAft>
+              <a:defRPr kumimoji="1" sz="1200">
+                <a:solidFill>
+                  <a:schemeClr val="tx1"/>
+                </a:solidFill>
+                <a:latin typeface="Arial" panose="020B0604020202020204" pitchFamily="34" charset="0"/>
+              </a:defRPr>
+            </a:lvl6pPr>
+            <a:lvl7pPr marL="2971800" indent="-228600" eaLnBrk="0" fontAlgn="base" hangingPunct="0">
+              <a:spcBef>
+                <a:spcPct val="30000"/>
+              </a:spcBef>
+              <a:spcAft>
+                <a:spcPct val="0"/>
+              </a:spcAft>
+              <a:defRPr kumimoji="1" sz="1200">
+                <a:solidFill>
+                  <a:schemeClr val="tx1"/>
+                </a:solidFill>
+                <a:latin typeface="Arial" panose="020B0604020202020204" pitchFamily="34" charset="0"/>
+              </a:defRPr>
+            </a:lvl7pPr>
+            <a:lvl8pPr marL="3429000" indent="-228600" eaLnBrk="0" fontAlgn="base" hangingPunct="0">
+              <a:spcBef>
+                <a:spcPct val="30000"/>
+              </a:spcBef>
+              <a:spcAft>
+                <a:spcPct val="0"/>
+              </a:spcAft>
+              <a:defRPr kumimoji="1" sz="1200">
+                <a:solidFill>
+                  <a:schemeClr val="tx1"/>
+                </a:solidFill>
+                <a:latin typeface="Arial" panose="020B0604020202020204" pitchFamily="34" charset="0"/>
+              </a:defRPr>
+            </a:lvl8pPr>
+            <a:lvl9pPr marL="3886200" indent="-228600" eaLnBrk="0" fontAlgn="base" hangingPunct="0">
+              <a:spcBef>
+                <a:spcPct val="30000"/>
+              </a:spcBef>
+              <a:spcAft>
+                <a:spcPct val="0"/>
+              </a:spcAft>
+              <a:defRPr kumimoji="1" sz="1200">
+                <a:solidFill>
+                  <a:schemeClr val="tx1"/>
+                </a:solidFill>
+                <a:latin typeface="Arial" panose="020B0604020202020204" pitchFamily="34" charset="0"/>
+              </a:defRPr>
+            </a:lvl9pPr>
+          </a:lstStyle>
+          <a:p>
+            <a:pPr>
+              <a:spcBef>
+                <a:spcPct val="0"/>
+              </a:spcBef>
+            </a:pPr>
+            <a:fld id="{2965FB0D-81DB-4A5B-A3ED-B3706CA0E5D3}" type="slidenum">
+              <a:rPr kumimoji="0" lang="es-ES" altLang="en-US"/>
+              <a:pPr>
+                <a:spcBef>
+                  <a:spcPct val="0"/>
+                </a:spcBef>
+              </a:pPr>
+              <a:t>44</a:t>
+            </a:fld>
+            <a:endParaRPr kumimoji="0" lang="es-ES" altLang="en-US"/>
+          </a:p>
+        </p:txBody>
+      </p:sp>
+      <p:sp>
+        <p:nvSpPr>
+          <p:cNvPr id="21507" name="Rectangle 2">
+            <a:extLst>
+              <a:ext uri="{FF2B5EF4-FFF2-40B4-BE49-F238E27FC236}">
+                <a16:creationId xmlns:a16="http://schemas.microsoft.com/office/drawing/2014/main" id="{A12BF216-6A1B-6F88-7EFA-B0E5A047A999}"/>
+              </a:ext>
+            </a:extLst>
+          </p:cNvPr>
+          <p:cNvSpPr>
+            <a:spLocks noGrp="1" noRot="1" noChangeAspect="1" noChangeArrowheads="1" noTextEdit="1"/>
+          </p:cNvSpPr>
+          <p:nvPr>
+            <p:ph type="sldImg"/>
+          </p:nvPr>
+        </p:nvSpPr>
+        <p:spPr>
+          <a:ln/>
+        </p:spPr>
+      </p:sp>
+      <p:sp>
+        <p:nvSpPr>
+          <p:cNvPr id="21508" name="Rectangle 3">
+            <a:extLst>
+              <a:ext uri="{FF2B5EF4-FFF2-40B4-BE49-F238E27FC236}">
+                <a16:creationId xmlns:a16="http://schemas.microsoft.com/office/drawing/2014/main" id="{0032BB52-A9F0-FC93-C25C-54B3AB5F3218}"/>
+              </a:ext>
+            </a:extLst>
+          </p:cNvPr>
+          <p:cNvSpPr>
+            <a:spLocks noGrp="1" noChangeArrowheads="1"/>
+          </p:cNvSpPr>
+          <p:nvPr>
+            <p:ph type="body" idx="1"/>
+          </p:nvPr>
+        </p:nvSpPr>
+        <p:spPr>
+          <a:noFill/>
+          <a:extLst>
+            <a:ext uri="{909E8E84-426E-40DD-AFC4-6F175D3DCCD1}">
+              <a14:hiddenFill xmlns:a14="http://schemas.microsoft.com/office/drawing/2010/main">
+                <a:solidFill>
+                  <a:schemeClr val="accent1"/>
+                </a:solidFill>
+              </a14:hiddenFill>
+            </a:ext>
+            <a:ext uri="{91240B29-F687-4F45-9708-019B960494DF}">
+              <a14:hiddenLine xmlns:a14="http://schemas.microsoft.com/office/drawing/2010/main" w="9525">
+                <a:solidFill>
+                  <a:schemeClr val="tx1"/>
+                </a:solidFill>
+                <a:miter lim="800000"/>
+                <a:headEnd/>
+                <a:tailEnd/>
+              </a14:hiddenLine>
+            </a:ext>
+            <a:ext uri="{AF507438-7753-43E0-B8FC-AC1667EBCBE1}">
+              <a14:hiddenEffects xmlns:a14="http://schemas.microsoft.com/office/drawing/2010/main">
+                <a:effectLst>
+                  <a:outerShdw dist="35921" dir="2700000" algn="ctr" rotWithShape="0">
+                    <a:schemeClr val="bg2"/>
+                  </a:outerShdw>
+                </a:effectLst>
+              </a14:hiddenEffects>
+            </a:ext>
+          </a:extLst>
+        </p:spPr>
+        <p:txBody>
+          <a:bodyPr/>
+          <a:lstStyle/>
+          <a:p>
+            <a:pPr eaLnBrk="1" hangingPunct="1"/>
+            <a:endParaRPr lang="es-ES" altLang="en-US">
+              <a:latin typeface="Arial" panose="020B0604020202020204" pitchFamily="34" charset="0"/>
+            </a:endParaRPr>
+          </a:p>
+        </p:txBody>
+      </p:sp>
+    </p:spTree>
+    <p:extLst>
+      <p:ext uri="{BB962C8B-B14F-4D97-AF65-F5344CB8AC3E}">
+        <p14:creationId xmlns:p14="http://schemas.microsoft.com/office/powerpoint/2010/main" val="3177508128"/>
+      </p:ext>
+    </p:extLst>
+  </p:cSld>
+  <p:clrMapOvr>
+    <a:masterClrMapping/>
+  </p:clrMapOvr>
+</p:notes>
+</file>
+
+<file path=ppt/notesSlides/notesSlide43.xml><?xml version="1.0" encoding="utf-8"?>
+<p:notes xmlns:a="http://schemas.openxmlformats.org/drawingml/2006/main" xmlns:r="http://schemas.openxmlformats.org/officeDocument/2006/relationships" xmlns:p="http://schemas.openxmlformats.org/presentationml/2006/main">
+  <p:cSld>
+    <p:spTree>
+      <p:nvGrpSpPr>
+        <p:cNvPr id="1" name=""/>
+        <p:cNvGrpSpPr/>
+        <p:nvPr/>
+      </p:nvGrpSpPr>
+      <p:grpSpPr>
+        <a:xfrm>
+          <a:off x="0" y="0"/>
+          <a:ext cx="0" cy="0"/>
+          <a:chOff x="0" y="0"/>
+          <a:chExt cx="0" cy="0"/>
+        </a:xfrm>
+      </p:grpSpPr>
+      <p:sp>
+        <p:nvSpPr>
+          <p:cNvPr id="23554" name="Rectangle 7">
+            <a:extLst>
+              <a:ext uri="{FF2B5EF4-FFF2-40B4-BE49-F238E27FC236}">
+                <a16:creationId xmlns:a16="http://schemas.microsoft.com/office/drawing/2014/main" id="{86E7A627-DDD5-B676-907C-AA6C945090B7}"/>
+              </a:ext>
+            </a:extLst>
+          </p:cNvPr>
+          <p:cNvSpPr>
+            <a:spLocks noGrp="1" noChangeArrowheads="1"/>
+          </p:cNvSpPr>
+          <p:nvPr>
+            <p:ph type="sldNum" sz="quarter" idx="5"/>
+          </p:nvPr>
+        </p:nvSpPr>
+        <p:spPr>
+          <a:noFill/>
+          <a:extLst>
+            <a:ext uri="{909E8E84-426E-40DD-AFC4-6F175D3DCCD1}">
+              <a14:hiddenFill xmlns:a14="http://schemas.microsoft.com/office/drawing/2010/main">
+                <a:solidFill>
+                  <a:schemeClr val="accent1"/>
+                </a:solidFill>
+              </a14:hiddenFill>
+            </a:ext>
+            <a:ext uri="{91240B29-F687-4F45-9708-019B960494DF}">
+              <a14:hiddenLine xmlns:a14="http://schemas.microsoft.com/office/drawing/2010/main" w="9525">
+                <a:solidFill>
+                  <a:schemeClr val="tx1"/>
+                </a:solidFill>
+                <a:miter lim="800000"/>
+                <a:headEnd/>
+                <a:tailEnd/>
+              </a14:hiddenLine>
+            </a:ext>
+            <a:ext uri="{AF507438-7753-43E0-B8FC-AC1667EBCBE1}">
+              <a14:hiddenEffects xmlns:a14="http://schemas.microsoft.com/office/drawing/2010/main">
+                <a:effectLst>
+                  <a:outerShdw dist="35921" dir="2700000" algn="ctr" rotWithShape="0">
+                    <a:schemeClr val="bg2"/>
+                  </a:outerShdw>
+                </a:effectLst>
+              </a14:hiddenEffects>
+            </a:ext>
+          </a:extLst>
+        </p:spPr>
+        <p:txBody>
+          <a:bodyPr/>
+          <a:lstStyle>
+            <a:lvl1pPr>
+              <a:spcBef>
+                <a:spcPct val="30000"/>
+              </a:spcBef>
+              <a:defRPr kumimoji="1" sz="1200">
+                <a:solidFill>
+                  <a:schemeClr val="tx1"/>
+                </a:solidFill>
+                <a:latin typeface="Arial" panose="020B0604020202020204" pitchFamily="34" charset="0"/>
+              </a:defRPr>
+            </a:lvl1pPr>
+            <a:lvl2pPr marL="742950" indent="-285750">
+              <a:spcBef>
+                <a:spcPct val="30000"/>
+              </a:spcBef>
+              <a:defRPr kumimoji="1" sz="1200">
+                <a:solidFill>
+                  <a:schemeClr val="tx1"/>
+                </a:solidFill>
+                <a:latin typeface="Arial" panose="020B0604020202020204" pitchFamily="34" charset="0"/>
+              </a:defRPr>
+            </a:lvl2pPr>
+            <a:lvl3pPr marL="1143000" indent="-228600">
+              <a:spcBef>
+                <a:spcPct val="30000"/>
+              </a:spcBef>
+              <a:defRPr kumimoji="1" sz="1200">
+                <a:solidFill>
+                  <a:schemeClr val="tx1"/>
+                </a:solidFill>
+                <a:latin typeface="Arial" panose="020B0604020202020204" pitchFamily="34" charset="0"/>
+              </a:defRPr>
+            </a:lvl3pPr>
+            <a:lvl4pPr marL="1600200" indent="-228600">
+              <a:spcBef>
+                <a:spcPct val="30000"/>
+              </a:spcBef>
+              <a:defRPr kumimoji="1" sz="1200">
+                <a:solidFill>
+                  <a:schemeClr val="tx1"/>
+                </a:solidFill>
+                <a:latin typeface="Arial" panose="020B0604020202020204" pitchFamily="34" charset="0"/>
+              </a:defRPr>
+            </a:lvl4pPr>
+            <a:lvl5pPr marL="2057400" indent="-228600">
+              <a:spcBef>
+                <a:spcPct val="30000"/>
+              </a:spcBef>
+              <a:defRPr kumimoji="1" sz="1200">
+                <a:solidFill>
+                  <a:schemeClr val="tx1"/>
+                </a:solidFill>
+                <a:latin typeface="Arial" panose="020B0604020202020204" pitchFamily="34" charset="0"/>
+              </a:defRPr>
+            </a:lvl5pPr>
+            <a:lvl6pPr marL="2514600" indent="-228600" eaLnBrk="0" fontAlgn="base" hangingPunct="0">
+              <a:spcBef>
+                <a:spcPct val="30000"/>
+              </a:spcBef>
+              <a:spcAft>
+                <a:spcPct val="0"/>
+              </a:spcAft>
+              <a:defRPr kumimoji="1" sz="1200">
+                <a:solidFill>
+                  <a:schemeClr val="tx1"/>
+                </a:solidFill>
+                <a:latin typeface="Arial" panose="020B0604020202020204" pitchFamily="34" charset="0"/>
+              </a:defRPr>
+            </a:lvl6pPr>
+            <a:lvl7pPr marL="2971800" indent="-228600" eaLnBrk="0" fontAlgn="base" hangingPunct="0">
+              <a:spcBef>
+                <a:spcPct val="30000"/>
+              </a:spcBef>
+              <a:spcAft>
+                <a:spcPct val="0"/>
+              </a:spcAft>
+              <a:defRPr kumimoji="1" sz="1200">
+                <a:solidFill>
+                  <a:schemeClr val="tx1"/>
+                </a:solidFill>
+                <a:latin typeface="Arial" panose="020B0604020202020204" pitchFamily="34" charset="0"/>
+              </a:defRPr>
+            </a:lvl7pPr>
+            <a:lvl8pPr marL="3429000" indent="-228600" eaLnBrk="0" fontAlgn="base" hangingPunct="0">
+              <a:spcBef>
+                <a:spcPct val="30000"/>
+              </a:spcBef>
+              <a:spcAft>
+                <a:spcPct val="0"/>
+              </a:spcAft>
+              <a:defRPr kumimoji="1" sz="1200">
+                <a:solidFill>
+                  <a:schemeClr val="tx1"/>
+                </a:solidFill>
+                <a:latin typeface="Arial" panose="020B0604020202020204" pitchFamily="34" charset="0"/>
+              </a:defRPr>
+            </a:lvl8pPr>
+            <a:lvl9pPr marL="3886200" indent="-228600" eaLnBrk="0" fontAlgn="base" hangingPunct="0">
+              <a:spcBef>
+                <a:spcPct val="30000"/>
+              </a:spcBef>
+              <a:spcAft>
+                <a:spcPct val="0"/>
+              </a:spcAft>
+              <a:defRPr kumimoji="1" sz="1200">
+                <a:solidFill>
+                  <a:schemeClr val="tx1"/>
+                </a:solidFill>
+                <a:latin typeface="Arial" panose="020B0604020202020204" pitchFamily="34" charset="0"/>
+              </a:defRPr>
+            </a:lvl9pPr>
+          </a:lstStyle>
+          <a:p>
+            <a:pPr>
+              <a:spcBef>
+                <a:spcPct val="0"/>
+              </a:spcBef>
+            </a:pPr>
+            <a:fld id="{C2D9BAF6-4B93-4EA6-A9A5-26CAE860A30B}" type="slidenum">
+              <a:rPr kumimoji="0" lang="es-ES" altLang="en-US"/>
+              <a:pPr>
+                <a:spcBef>
+                  <a:spcPct val="0"/>
+                </a:spcBef>
+              </a:pPr>
+              <a:t>45</a:t>
+            </a:fld>
+            <a:endParaRPr kumimoji="0" lang="es-ES" altLang="en-US"/>
+          </a:p>
+        </p:txBody>
+      </p:sp>
+      <p:sp>
+        <p:nvSpPr>
+          <p:cNvPr id="23555" name="Rectangle 2">
+            <a:extLst>
+              <a:ext uri="{FF2B5EF4-FFF2-40B4-BE49-F238E27FC236}">
+                <a16:creationId xmlns:a16="http://schemas.microsoft.com/office/drawing/2014/main" id="{8A9599AD-C52C-C1EA-E9D2-846998CB051F}"/>
+              </a:ext>
+            </a:extLst>
+          </p:cNvPr>
+          <p:cNvSpPr>
+            <a:spLocks noGrp="1" noRot="1" noChangeAspect="1" noChangeArrowheads="1" noTextEdit="1"/>
+          </p:cNvSpPr>
+          <p:nvPr>
+            <p:ph type="sldImg"/>
+          </p:nvPr>
+        </p:nvSpPr>
+        <p:spPr>
+          <a:ln/>
+        </p:spPr>
+      </p:sp>
+      <p:sp>
+        <p:nvSpPr>
+          <p:cNvPr id="23556" name="Rectangle 3">
+            <a:extLst>
+              <a:ext uri="{FF2B5EF4-FFF2-40B4-BE49-F238E27FC236}">
+                <a16:creationId xmlns:a16="http://schemas.microsoft.com/office/drawing/2014/main" id="{CDA498A1-19D2-FB11-A95E-324A065D7BDF}"/>
+              </a:ext>
+            </a:extLst>
+          </p:cNvPr>
+          <p:cNvSpPr>
+            <a:spLocks noGrp="1" noChangeArrowheads="1"/>
+          </p:cNvSpPr>
+          <p:nvPr>
+            <p:ph type="body" idx="1"/>
+          </p:nvPr>
+        </p:nvSpPr>
+        <p:spPr>
+          <a:noFill/>
+          <a:extLst>
+            <a:ext uri="{909E8E84-426E-40DD-AFC4-6F175D3DCCD1}">
+              <a14:hiddenFill xmlns:a14="http://schemas.microsoft.com/office/drawing/2010/main">
+                <a:solidFill>
+                  <a:schemeClr val="accent1"/>
+                </a:solidFill>
+              </a14:hiddenFill>
+            </a:ext>
+            <a:ext uri="{91240B29-F687-4F45-9708-019B960494DF}">
+              <a14:hiddenLine xmlns:a14="http://schemas.microsoft.com/office/drawing/2010/main" w="9525">
+                <a:solidFill>
+                  <a:schemeClr val="tx1"/>
+                </a:solidFill>
+                <a:miter lim="800000"/>
+                <a:headEnd/>
+                <a:tailEnd/>
+              </a14:hiddenLine>
+            </a:ext>
+            <a:ext uri="{AF507438-7753-43E0-B8FC-AC1667EBCBE1}">
+              <a14:hiddenEffects xmlns:a14="http://schemas.microsoft.com/office/drawing/2010/main">
+                <a:effectLst>
+                  <a:outerShdw dist="35921" dir="2700000" algn="ctr" rotWithShape="0">
+                    <a:schemeClr val="bg2"/>
+                  </a:outerShdw>
+                </a:effectLst>
+              </a14:hiddenEffects>
+            </a:ext>
+          </a:extLst>
+        </p:spPr>
+        <p:txBody>
+          <a:bodyPr/>
+          <a:lstStyle/>
+          <a:p>
+            <a:pPr eaLnBrk="1" hangingPunct="1"/>
+            <a:endParaRPr lang="es-ES" altLang="en-US">
+              <a:latin typeface="Arial" panose="020B0604020202020204" pitchFamily="34" charset="0"/>
+            </a:endParaRPr>
+          </a:p>
+        </p:txBody>
+      </p:sp>
+    </p:spTree>
+  </p:cSld>
+  <p:clrMapOvr>
+    <a:masterClrMapping/>
+  </p:clrMapOvr>
+</p:notes>
+</file>
+
+<file path=ppt/notesSlides/notesSlide44.xml><?xml version="1.0" encoding="utf-8"?>
+<p:notes xmlns:a="http://schemas.openxmlformats.org/drawingml/2006/main" xmlns:r="http://schemas.openxmlformats.org/officeDocument/2006/relationships" xmlns:p="http://schemas.openxmlformats.org/presentationml/2006/main">
+  <p:cSld>
+    <p:spTree>
+      <p:nvGrpSpPr>
         <p:cNvPr id="1" name=""/>
         <p:cNvGrpSpPr/>
         <p:nvPr/>
@@ -11932,7 +13103,7 @@
                   <a:spcPct val="0"/>
                 </a:spcBef>
               </a:pPr>
-              <a:t>42</a:t>
+              <a:t>46</a:t>
             </a:fld>
             <a:endParaRPr kumimoji="0" lang="es-ES" altLang="en-US"/>
           </a:p>
@@ -12024,7 +13195,7 @@
 </p:notes>
 </file>
 
-<file path=ppt/notesSlides/notesSlide41.xml><?xml version="1.0" encoding="utf-8"?>
+<file path=ppt/notesSlides/notesSlide45.xml><?xml version="1.0" encoding="utf-8"?>
 <p:notes xmlns:a="http://schemas.openxmlformats.org/drawingml/2006/main" xmlns:r="http://schemas.openxmlformats.org/officeDocument/2006/relationships" xmlns:p="http://schemas.openxmlformats.org/presentationml/2006/main">
   <p:cSld>
     <p:spTree>
@@ -12216,7 +13387,7 @@
                   <a:spcPct val="0"/>
                 </a:spcBef>
               </a:pPr>
-              <a:t>43</a:t>
+              <a:t>47</a:t>
             </a:fld>
             <a:endParaRPr kumimoji="0" lang="es-ES" altLang="en-US"/>
           </a:p>
@@ -14536,7 +15707,7 @@
               <a:pPr>
                 <a:defRPr/>
               </a:pPr>
-              <a:t>‹Nº›</a:t>
+              <a:t>‹#›</a:t>
             </a:fld>
             <a:endParaRPr lang="es-ES" altLang="en-US"/>
           </a:p>
@@ -14748,7 +15919,7 @@
               <a:pPr>
                 <a:defRPr/>
               </a:pPr>
-              <a:t>‹Nº›</a:t>
+              <a:t>‹#›</a:t>
             </a:fld>
             <a:endParaRPr lang="es-ES" altLang="en-US"/>
           </a:p>
@@ -14970,7 +16141,7 @@
               <a:pPr>
                 <a:defRPr/>
               </a:pPr>
-              <a:t>‹Nº›</a:t>
+              <a:t>‹#›</a:t>
             </a:fld>
             <a:endParaRPr lang="es-ES" altLang="en-US"/>
           </a:p>
@@ -15182,7 +16353,7 @@
               <a:pPr>
                 <a:defRPr/>
               </a:pPr>
-              <a:t>‹Nº›</a:t>
+              <a:t>‹#›</a:t>
             </a:fld>
             <a:endParaRPr lang="es-ES" altLang="en-US"/>
           </a:p>
@@ -15417,7 +16588,7 @@
               <a:pPr>
                 <a:defRPr/>
               </a:pPr>
-              <a:t>‹Nº›</a:t>
+              <a:t>‹#›</a:t>
             </a:fld>
             <a:endParaRPr lang="es-ES" altLang="en-US"/>
           </a:p>
@@ -15746,7 +16917,7 @@
               <a:pPr>
                 <a:defRPr/>
               </a:pPr>
-              <a:t>‹Nº›</a:t>
+              <a:t>‹#›</a:t>
             </a:fld>
             <a:endParaRPr lang="es-ES" altLang="en-US"/>
           </a:p>
@@ -16214,7 +17385,7 @@
               <a:pPr>
                 <a:defRPr/>
               </a:pPr>
-              <a:t>‹Nº›</a:t>
+              <a:t>‹#›</a:t>
             </a:fld>
             <a:endParaRPr lang="es-ES" altLang="en-US"/>
           </a:p>
@@ -16375,7 +17546,7 @@
               <a:pPr>
                 <a:defRPr/>
               </a:pPr>
-              <a:t>‹Nº›</a:t>
+              <a:t>‹#›</a:t>
             </a:fld>
             <a:endParaRPr lang="es-ES" altLang="en-US"/>
           </a:p>
@@ -16514,7 +17685,7 @@
               <a:pPr>
                 <a:defRPr/>
               </a:pPr>
-              <a:t>‹Nº›</a:t>
+              <a:t>‹#›</a:t>
             </a:fld>
             <a:endParaRPr lang="es-ES" altLang="en-US"/>
           </a:p>
@@ -16833,7 +18004,7 @@
               <a:pPr>
                 <a:defRPr/>
               </a:pPr>
-              <a:t>‹Nº›</a:t>
+              <a:t>‹#›</a:t>
             </a:fld>
             <a:endParaRPr lang="es-ES" altLang="en-US"/>
           </a:p>
@@ -17130,7 +18301,7 @@
               <a:pPr>
                 <a:defRPr/>
               </a:pPr>
-              <a:t>‹Nº›</a:t>
+              <a:t>‹#›</a:t>
             </a:fld>
             <a:endParaRPr lang="es-ES" altLang="en-US"/>
           </a:p>
@@ -17949,7 +19120,7 @@
               <a:pPr>
                 <a:defRPr/>
               </a:pPr>
-              <a:t>‹Nº›</a:t>
+              <a:t>‹#›</a:t>
             </a:fld>
             <a:endParaRPr lang="es-ES" altLang="en-US"/>
           </a:p>
@@ -30039,10 +31210,10 @@
       </p:sp>
       <p:pic>
         <p:nvPicPr>
-          <p:cNvPr id="2" name="Imagen 7">
+          <p:cNvPr id="3" name="Imagen 4">
             <a:extLst>
               <a:ext uri="{FF2B5EF4-FFF2-40B4-BE49-F238E27FC236}">
-                <a16:creationId xmlns:a16="http://schemas.microsoft.com/office/drawing/2014/main" id="{016E6150-4D5E-0C58-A5AC-B60A4C0BD3A0}"/>
+                <a16:creationId xmlns:a16="http://schemas.microsoft.com/office/drawing/2014/main" id="{725C6B60-5B5F-2656-8A5A-E43F557018CB}"/>
               </a:ext>
             </a:extLst>
           </p:cNvPr>
@@ -30059,8 +31230,8 @@
         </p:blipFill>
         <p:spPr>
           <a:xfrm>
-            <a:off x="914400" y="2204864"/>
-            <a:ext cx="7635115" cy="3750465"/>
+            <a:off x="1115616" y="2348880"/>
+            <a:ext cx="7221035" cy="3544739"/>
           </a:xfrm>
           <a:prstGeom prst="rect">
             <a:avLst/>
@@ -30088,7 +31259,7 @@
         <p:cNvPr id="1" name="">
           <a:extLst>
             <a:ext uri="{FF2B5EF4-FFF2-40B4-BE49-F238E27FC236}">
-              <a16:creationId xmlns:a16="http://schemas.microsoft.com/office/drawing/2014/main" id="{9CC41E07-E489-FFA5-4FC8-A97172CF0F2F}"/>
+              <a16:creationId xmlns:a16="http://schemas.microsoft.com/office/drawing/2014/main" id="{0E289152-90D5-B1CA-31BD-1318252CF9F9}"/>
             </a:ext>
           </a:extLst>
         </p:cNvPr>
@@ -30108,7 +31279,7 @@
           <p:cNvPr id="8194" name="Rectangle 2">
             <a:extLst>
               <a:ext uri="{FF2B5EF4-FFF2-40B4-BE49-F238E27FC236}">
-                <a16:creationId xmlns:a16="http://schemas.microsoft.com/office/drawing/2014/main" id="{4FA70FC8-05A1-4A90-B578-61641BFFF1FB}"/>
+                <a16:creationId xmlns:a16="http://schemas.microsoft.com/office/drawing/2014/main" id="{E6608120-C406-F4DC-C100-70B54E0047D4}"/>
               </a:ext>
             </a:extLst>
           </p:cNvPr>
@@ -30132,667 +31303,30 @@
           </a:p>
         </p:txBody>
       </p:sp>
-      <p:sp>
-        <p:nvSpPr>
-          <p:cNvPr id="3" name="object 3">
+      <p:pic>
+        <p:nvPicPr>
+          <p:cNvPr id="2" name="Imagen 3">
             <a:extLst>
               <a:ext uri="{FF2B5EF4-FFF2-40B4-BE49-F238E27FC236}">
-                <a16:creationId xmlns:a16="http://schemas.microsoft.com/office/drawing/2014/main" id="{DECB7BB4-B31F-10CC-8A6F-087587099716}"/>
+                <a16:creationId xmlns:a16="http://schemas.microsoft.com/office/drawing/2014/main" id="{D90BAE3B-A816-7A5A-FDF0-801F4BB23ECE}"/>
               </a:ext>
             </a:extLst>
           </p:cNvPr>
-          <p:cNvSpPr txBox="1"/>
-          <p:nvPr/>
-        </p:nvSpPr>
-        <p:spPr>
-          <a:xfrm>
-            <a:off x="1043608" y="1846106"/>
-            <a:ext cx="7166561" cy="3726661"/>
-          </a:xfrm>
-          <a:prstGeom prst="rect">
-            <a:avLst/>
-          </a:prstGeom>
-        </p:spPr>
-        <p:txBody>
-          <a:bodyPr vert="horz" wrap="square" lIns="0" tIns="12700" rIns="0" bIns="0" rtlCol="0">
-            <a:spAutoFit/>
-          </a:bodyPr>
-          <a:lstStyle/>
-          <a:p>
-            <a:pPr marL="12700">
-              <a:lnSpc>
-                <a:spcPct val="100000"/>
-              </a:lnSpc>
-              <a:spcBef>
-                <a:spcPts val="100"/>
-              </a:spcBef>
-            </a:pPr>
-            <a:r>
-              <a:rPr sz="2000" b="1" spc="-10" dirty="0">
-                <a:latin typeface="Verdana"/>
-                <a:cs typeface="Verdana"/>
-              </a:rPr>
-              <a:t>Clases</a:t>
-            </a:r>
-            <a:r>
-              <a:rPr sz="2000" b="1" spc="-5" dirty="0">
-                <a:latin typeface="Verdana"/>
-                <a:cs typeface="Verdana"/>
-              </a:rPr>
-              <a:t> </a:t>
-            </a:r>
-            <a:r>
-              <a:rPr sz="2000" b="1" dirty="0">
-                <a:latin typeface="Verdana"/>
-                <a:cs typeface="Verdana"/>
-              </a:rPr>
-              <a:t>y</a:t>
-            </a:r>
-            <a:r>
-              <a:rPr sz="2000" b="1" spc="-5" dirty="0">
-                <a:latin typeface="Verdana"/>
-                <a:cs typeface="Verdana"/>
-              </a:rPr>
-              <a:t> objetos</a:t>
-            </a:r>
-            <a:endParaRPr sz="2000" dirty="0">
-              <a:latin typeface="Verdana"/>
-              <a:cs typeface="Verdana"/>
-            </a:endParaRPr>
-          </a:p>
-          <a:p>
-            <a:pPr>
-              <a:lnSpc>
-                <a:spcPct val="100000"/>
-              </a:lnSpc>
-              <a:spcBef>
-                <a:spcPts val="15"/>
-              </a:spcBef>
-            </a:pPr>
-            <a:endParaRPr sz="2750" dirty="0">
-              <a:latin typeface="Verdana"/>
-              <a:cs typeface="Verdana"/>
-            </a:endParaRPr>
-          </a:p>
-          <a:p>
-            <a:pPr marL="355600" marR="5080" indent="-342900" algn="just">
-              <a:lnSpc>
-                <a:spcPct val="100000"/>
-              </a:lnSpc>
-              <a:buClr>
-                <a:srgbClr val="D32D50"/>
-              </a:buClr>
-              <a:buFont typeface="Wingdings"/>
-              <a:buChar char=""/>
-              <a:tabLst>
-                <a:tab pos="355600" algn="l"/>
-              </a:tabLst>
-            </a:pPr>
-            <a:r>
-              <a:rPr sz="2000" b="1" dirty="0">
-                <a:latin typeface="Verdana"/>
-                <a:cs typeface="Verdana"/>
-              </a:rPr>
-              <a:t>La</a:t>
-            </a:r>
-            <a:r>
-              <a:rPr sz="2000" b="1" spc="5" dirty="0">
-                <a:latin typeface="Verdana"/>
-                <a:cs typeface="Verdana"/>
-              </a:rPr>
-              <a:t> </a:t>
-            </a:r>
-            <a:r>
-              <a:rPr sz="2000" b="1" spc="-5" dirty="0">
-                <a:latin typeface="Verdana"/>
-                <a:cs typeface="Verdana"/>
-              </a:rPr>
-              <a:t>interfaz</a:t>
-            </a:r>
-            <a:r>
-              <a:rPr sz="2000" b="1" dirty="0">
-                <a:latin typeface="Verdana"/>
-                <a:cs typeface="Verdana"/>
-              </a:rPr>
-              <a:t> ofrece</a:t>
-            </a:r>
-            <a:r>
-              <a:rPr sz="2000" b="1" spc="5" dirty="0">
-                <a:latin typeface="Verdana"/>
-                <a:cs typeface="Verdana"/>
-              </a:rPr>
-              <a:t> </a:t>
-            </a:r>
-            <a:r>
-              <a:rPr sz="2000" b="1" spc="-5" dirty="0">
-                <a:latin typeface="Verdana"/>
-                <a:cs typeface="Verdana"/>
-              </a:rPr>
-              <a:t>al</a:t>
-            </a:r>
-            <a:r>
-              <a:rPr sz="2000" b="1" dirty="0">
-                <a:latin typeface="Verdana"/>
-                <a:cs typeface="Verdana"/>
-              </a:rPr>
-              <a:t> </a:t>
-            </a:r>
-            <a:r>
-              <a:rPr sz="2000" b="1" spc="-5" dirty="0">
-                <a:latin typeface="Verdana"/>
-                <a:cs typeface="Verdana"/>
-              </a:rPr>
-              <a:t>exterior</a:t>
-            </a:r>
-            <a:r>
-              <a:rPr sz="2000" b="1" dirty="0">
-                <a:latin typeface="Verdana"/>
-                <a:cs typeface="Verdana"/>
-              </a:rPr>
-              <a:t> el</a:t>
-            </a:r>
-            <a:r>
-              <a:rPr sz="2000" b="1" spc="5" dirty="0">
-                <a:latin typeface="Verdana"/>
-                <a:cs typeface="Verdana"/>
-              </a:rPr>
-              <a:t> </a:t>
-            </a:r>
-            <a:r>
-              <a:rPr sz="2000" b="1" spc="-5" dirty="0">
-                <a:latin typeface="Verdana"/>
-                <a:cs typeface="Verdana"/>
-              </a:rPr>
-              <a:t>comportamiento</a:t>
-            </a:r>
-            <a:r>
-              <a:rPr sz="2000" b="1" dirty="0">
-                <a:latin typeface="Verdana"/>
-                <a:cs typeface="Verdana"/>
-              </a:rPr>
-              <a:t> </a:t>
-            </a:r>
-            <a:r>
-              <a:rPr sz="2000" b="1" spc="-10" dirty="0">
-                <a:latin typeface="Verdana"/>
-                <a:cs typeface="Verdana"/>
-              </a:rPr>
-              <a:t>del </a:t>
-            </a:r>
-            <a:r>
-              <a:rPr sz="2000" b="1" spc="-5" dirty="0">
-                <a:latin typeface="Verdana"/>
-                <a:cs typeface="Verdana"/>
-              </a:rPr>
-              <a:t> objeto. </a:t>
-            </a:r>
-            <a:r>
-              <a:rPr sz="2000" b="1" spc="-10" dirty="0">
-                <a:latin typeface="Verdana"/>
-                <a:cs typeface="Verdana"/>
-              </a:rPr>
-              <a:t>El </a:t>
-            </a:r>
-            <a:r>
-              <a:rPr sz="2000" b="1" spc="-5" dirty="0">
-                <a:latin typeface="Verdana"/>
-                <a:cs typeface="Verdana"/>
-              </a:rPr>
-              <a:t>código </a:t>
-            </a:r>
-            <a:r>
-              <a:rPr sz="2000" b="1" dirty="0">
-                <a:latin typeface="Verdana"/>
-                <a:cs typeface="Verdana"/>
-              </a:rPr>
-              <a:t>y </a:t>
-            </a:r>
-            <a:r>
-              <a:rPr sz="2000" b="1" spc="-5" dirty="0">
-                <a:latin typeface="Verdana"/>
-                <a:cs typeface="Verdana"/>
-              </a:rPr>
-              <a:t>los </a:t>
-            </a:r>
-            <a:r>
-              <a:rPr sz="2000" b="1" dirty="0">
-                <a:latin typeface="Verdana"/>
-                <a:cs typeface="Verdana"/>
-              </a:rPr>
-              <a:t>datos internos </a:t>
-            </a:r>
-            <a:r>
-              <a:rPr sz="2000" b="1" spc="-5" dirty="0">
-                <a:latin typeface="Verdana"/>
-                <a:cs typeface="Verdana"/>
-              </a:rPr>
-              <a:t>que </a:t>
-            </a:r>
-            <a:r>
-              <a:rPr sz="2000" b="1" dirty="0">
-                <a:latin typeface="Verdana"/>
-                <a:cs typeface="Verdana"/>
-              </a:rPr>
-              <a:t>se </a:t>
-            </a:r>
-            <a:r>
-              <a:rPr sz="2000" b="1" spc="-5" dirty="0">
-                <a:latin typeface="Verdana"/>
-                <a:cs typeface="Verdana"/>
-              </a:rPr>
-              <a:t>utilizan para </a:t>
-            </a:r>
-            <a:r>
-              <a:rPr sz="2000" b="1" dirty="0">
-                <a:latin typeface="Verdana"/>
-                <a:cs typeface="Verdana"/>
-              </a:rPr>
-              <a:t> </a:t>
-            </a:r>
-            <a:r>
-              <a:rPr sz="2000" b="1" spc="-5" dirty="0">
-                <a:latin typeface="Verdana"/>
-                <a:cs typeface="Verdana"/>
-              </a:rPr>
-              <a:t>responder</a:t>
-            </a:r>
-            <a:r>
-              <a:rPr sz="2000" b="1" dirty="0">
-                <a:latin typeface="Verdana"/>
-                <a:cs typeface="Verdana"/>
-              </a:rPr>
-              <a:t> </a:t>
-            </a:r>
-            <a:r>
-              <a:rPr sz="2000" b="1" spc="-5" dirty="0">
-                <a:latin typeface="Verdana"/>
-                <a:cs typeface="Verdana"/>
-              </a:rPr>
-              <a:t>a</a:t>
-            </a:r>
-            <a:r>
-              <a:rPr sz="2000" b="1" spc="20" dirty="0">
-                <a:latin typeface="Verdana"/>
-                <a:cs typeface="Verdana"/>
-              </a:rPr>
-              <a:t> </a:t>
-            </a:r>
-            <a:r>
-              <a:rPr sz="2000" b="1" spc="-5" dirty="0">
-                <a:latin typeface="Verdana"/>
-                <a:cs typeface="Verdana"/>
-              </a:rPr>
-              <a:t>una</a:t>
-            </a:r>
-            <a:r>
-              <a:rPr sz="2000" b="1" dirty="0">
-                <a:latin typeface="Verdana"/>
-                <a:cs typeface="Verdana"/>
-              </a:rPr>
-              <a:t> </a:t>
-            </a:r>
-            <a:r>
-              <a:rPr sz="2000" b="1" spc="-5" dirty="0">
-                <a:latin typeface="Verdana"/>
-                <a:cs typeface="Verdana"/>
-              </a:rPr>
-              <a:t>petición</a:t>
-            </a:r>
-            <a:r>
-              <a:rPr sz="2000" b="1" spc="15" dirty="0">
-                <a:latin typeface="Verdana"/>
-                <a:cs typeface="Verdana"/>
-              </a:rPr>
-              <a:t> </a:t>
-            </a:r>
-            <a:r>
-              <a:rPr sz="2000" b="1" spc="-10" dirty="0">
-                <a:latin typeface="Verdana"/>
-                <a:cs typeface="Verdana"/>
-              </a:rPr>
-              <a:t>se</a:t>
-            </a:r>
-            <a:r>
-              <a:rPr sz="2000" b="1" spc="5" dirty="0">
-                <a:latin typeface="Verdana"/>
-                <a:cs typeface="Verdana"/>
-              </a:rPr>
-              <a:t> </a:t>
-            </a:r>
-            <a:r>
-              <a:rPr sz="2000" b="1" spc="-5" dirty="0">
-                <a:latin typeface="Verdana"/>
-                <a:cs typeface="Verdana"/>
-              </a:rPr>
-              <a:t>denomina</a:t>
-            </a:r>
-            <a:r>
-              <a:rPr sz="2000" b="1" spc="20" dirty="0">
-                <a:latin typeface="Verdana"/>
-                <a:cs typeface="Verdana"/>
-              </a:rPr>
-              <a:t> </a:t>
-            </a:r>
-            <a:r>
-              <a:rPr sz="2000" b="1" spc="-5" dirty="0">
-                <a:latin typeface="Verdana"/>
-                <a:cs typeface="Verdana"/>
-              </a:rPr>
-              <a:t>implementación</a:t>
-            </a:r>
-            <a:endParaRPr sz="2000" dirty="0">
-              <a:latin typeface="Verdana"/>
-              <a:cs typeface="Verdana"/>
-            </a:endParaRPr>
-          </a:p>
-          <a:p>
-            <a:pPr>
-              <a:lnSpc>
-                <a:spcPct val="100000"/>
-              </a:lnSpc>
-              <a:spcBef>
-                <a:spcPts val="20"/>
-              </a:spcBef>
-              <a:buClr>
-                <a:srgbClr val="D32D50"/>
-              </a:buClr>
-              <a:buFont typeface="Wingdings"/>
-              <a:buChar char=""/>
-            </a:pPr>
-            <a:endParaRPr sz="2750" dirty="0">
-              <a:latin typeface="Verdana"/>
-              <a:cs typeface="Verdana"/>
-            </a:endParaRPr>
-          </a:p>
-          <a:p>
-            <a:pPr marL="355600" indent="-342900">
-              <a:lnSpc>
-                <a:spcPct val="100000"/>
-              </a:lnSpc>
-              <a:buClr>
-                <a:srgbClr val="D32D50"/>
-              </a:buClr>
-              <a:buFont typeface="Wingdings"/>
-              <a:buChar char=""/>
-              <a:tabLst>
-                <a:tab pos="354965" algn="l"/>
-                <a:tab pos="355600" algn="l"/>
-              </a:tabLst>
-            </a:pPr>
-            <a:r>
-              <a:rPr sz="2000" b="1" spc="-5" dirty="0">
-                <a:latin typeface="Verdana"/>
-                <a:cs typeface="Verdana"/>
-              </a:rPr>
-              <a:t>Un</a:t>
-            </a:r>
-            <a:r>
-              <a:rPr sz="2000" b="1" spc="-20" dirty="0">
-                <a:latin typeface="Verdana"/>
-                <a:cs typeface="Verdana"/>
-              </a:rPr>
-              <a:t> </a:t>
-            </a:r>
-            <a:r>
-              <a:rPr sz="2000" b="1" spc="-5" dirty="0">
-                <a:latin typeface="Verdana"/>
-                <a:cs typeface="Verdana"/>
-              </a:rPr>
-              <a:t>objeto </a:t>
-            </a:r>
-            <a:r>
-              <a:rPr sz="2000" b="1" spc="-10" dirty="0">
-                <a:latin typeface="Verdana"/>
-                <a:cs typeface="Verdana"/>
-              </a:rPr>
-              <a:t>se</a:t>
-            </a:r>
-            <a:r>
-              <a:rPr sz="2000" b="1" dirty="0">
-                <a:latin typeface="Verdana"/>
-                <a:cs typeface="Verdana"/>
-              </a:rPr>
-              <a:t> </a:t>
-            </a:r>
-            <a:r>
-              <a:rPr sz="2000" b="1" spc="-5" dirty="0">
-                <a:latin typeface="Verdana"/>
-                <a:cs typeface="Verdana"/>
-              </a:rPr>
-              <a:t>compone</a:t>
-            </a:r>
-            <a:r>
-              <a:rPr sz="2000" b="1" spc="-40" dirty="0">
-                <a:latin typeface="Verdana"/>
-                <a:cs typeface="Verdana"/>
-              </a:rPr>
-              <a:t> </a:t>
-            </a:r>
-            <a:r>
-              <a:rPr sz="2000" b="1" spc="-10" dirty="0">
-                <a:latin typeface="Verdana"/>
-                <a:cs typeface="Verdana"/>
-              </a:rPr>
-              <a:t>de:</a:t>
-            </a:r>
-            <a:endParaRPr sz="2000" dirty="0">
-              <a:latin typeface="Verdana"/>
-              <a:cs typeface="Verdana"/>
-            </a:endParaRPr>
-          </a:p>
-          <a:p>
-            <a:pPr>
-              <a:lnSpc>
-                <a:spcPct val="100000"/>
-              </a:lnSpc>
-              <a:spcBef>
-                <a:spcPts val="35"/>
-              </a:spcBef>
-              <a:buClr>
-                <a:srgbClr val="D32D50"/>
-              </a:buClr>
-              <a:buFont typeface="Wingdings"/>
-              <a:buChar char=""/>
-            </a:pPr>
-            <a:endParaRPr sz="2700" dirty="0">
-              <a:latin typeface="Verdana"/>
-              <a:cs typeface="Verdana"/>
-            </a:endParaRPr>
-          </a:p>
-          <a:p>
-            <a:pPr marL="756920" lvl="1" indent="-287020">
-              <a:lnSpc>
-                <a:spcPct val="100000"/>
-              </a:lnSpc>
-              <a:spcBef>
-                <a:spcPts val="5"/>
-              </a:spcBef>
-              <a:buClr>
-                <a:srgbClr val="D32D50"/>
-              </a:buClr>
-              <a:buFont typeface="Wingdings"/>
-              <a:buChar char=""/>
-              <a:tabLst>
-                <a:tab pos="756920" algn="l"/>
-              </a:tabLst>
-            </a:pPr>
-            <a:r>
-              <a:rPr sz="1800" b="1" spc="-5" dirty="0">
-                <a:latin typeface="Verdana"/>
-                <a:cs typeface="Verdana"/>
-              </a:rPr>
-              <a:t>Interfaz:</a:t>
-            </a:r>
-            <a:r>
-              <a:rPr sz="1800" b="1" spc="-10" dirty="0">
-                <a:latin typeface="Verdana"/>
-                <a:cs typeface="Verdana"/>
-              </a:rPr>
-              <a:t> </a:t>
-            </a:r>
-            <a:r>
-              <a:rPr sz="1800" b="1" spc="-5" dirty="0">
-                <a:latin typeface="Verdana"/>
-                <a:cs typeface="Verdana"/>
-              </a:rPr>
-              <a:t>qué </a:t>
-            </a:r>
-            <a:r>
-              <a:rPr sz="1800" b="1" spc="-10" dirty="0">
-                <a:latin typeface="Verdana"/>
-                <a:cs typeface="Verdana"/>
-              </a:rPr>
-              <a:t>se</a:t>
-            </a:r>
-            <a:r>
-              <a:rPr sz="1800" b="1" dirty="0">
-                <a:latin typeface="Verdana"/>
-                <a:cs typeface="Verdana"/>
-              </a:rPr>
-              <a:t> ofrece</a:t>
-            </a:r>
-            <a:endParaRPr sz="1800" dirty="0">
-              <a:latin typeface="Verdana"/>
-              <a:cs typeface="Verdana"/>
-            </a:endParaRPr>
-          </a:p>
-          <a:p>
-            <a:pPr marL="756920" lvl="1" indent="-287020">
-              <a:lnSpc>
-                <a:spcPct val="100000"/>
-              </a:lnSpc>
-              <a:spcBef>
-                <a:spcPts val="439"/>
-              </a:spcBef>
-              <a:buClr>
-                <a:srgbClr val="D32D50"/>
-              </a:buClr>
-              <a:buFont typeface="Wingdings"/>
-              <a:buChar char=""/>
-              <a:tabLst>
-                <a:tab pos="756920" algn="l"/>
-              </a:tabLst>
-            </a:pPr>
-            <a:r>
-              <a:rPr sz="1800" b="1" spc="-5" dirty="0">
-                <a:latin typeface="Verdana"/>
-                <a:cs typeface="Verdana"/>
-              </a:rPr>
-              <a:t>Implementación: cómo</a:t>
-            </a:r>
-            <a:r>
-              <a:rPr sz="1800" b="1" spc="-20" dirty="0">
-                <a:latin typeface="Verdana"/>
-                <a:cs typeface="Verdana"/>
-              </a:rPr>
-              <a:t> </a:t>
-            </a:r>
-            <a:r>
-              <a:rPr sz="1800" b="1" spc="-10" dirty="0">
-                <a:latin typeface="Verdana"/>
-                <a:cs typeface="Verdana"/>
-              </a:rPr>
-              <a:t>se</a:t>
-            </a:r>
-            <a:r>
-              <a:rPr sz="1800" b="1" dirty="0">
-                <a:latin typeface="Verdana"/>
-                <a:cs typeface="Verdana"/>
-              </a:rPr>
-              <a:t> ofrece</a:t>
-            </a:r>
-            <a:endParaRPr sz="1800" dirty="0">
-              <a:latin typeface="Verdana"/>
-              <a:cs typeface="Verdana"/>
-            </a:endParaRPr>
-          </a:p>
-        </p:txBody>
-      </p:sp>
-      <p:sp>
-        <p:nvSpPr>
-          <p:cNvPr id="4" name="object 4">
-            <a:extLst>
-              <a:ext uri="{FF2B5EF4-FFF2-40B4-BE49-F238E27FC236}">
-                <a16:creationId xmlns:a16="http://schemas.microsoft.com/office/drawing/2014/main" id="{4D157B51-07AE-DF4C-C331-2F63A4BA34D0}"/>
-              </a:ext>
-            </a:extLst>
-          </p:cNvPr>
-          <p:cNvSpPr txBox="1"/>
-          <p:nvPr/>
-        </p:nvSpPr>
-        <p:spPr>
-          <a:xfrm>
-            <a:off x="1500809" y="5945667"/>
-            <a:ext cx="3143632" cy="637547"/>
-          </a:xfrm>
-          <a:prstGeom prst="rect">
-            <a:avLst/>
-          </a:prstGeom>
-        </p:spPr>
-        <p:txBody>
-          <a:bodyPr vert="horz" wrap="square" lIns="0" tIns="12700" rIns="0" bIns="0" rtlCol="0">
-            <a:spAutoFit/>
-          </a:bodyPr>
-          <a:lstStyle/>
-          <a:p>
-            <a:pPr marL="12700" marR="5080">
-              <a:lnSpc>
-                <a:spcPct val="119400"/>
-              </a:lnSpc>
-              <a:spcBef>
-                <a:spcPts val="100"/>
-              </a:spcBef>
-            </a:pPr>
-            <a:r>
-              <a:rPr sz="1800" b="1" spc="-5" dirty="0">
-                <a:latin typeface="Verdana"/>
-                <a:cs typeface="Verdana"/>
-              </a:rPr>
-              <a:t>Light bombilla = new Light(); </a:t>
-            </a:r>
-            <a:r>
-              <a:rPr sz="1800" b="1" spc="-605" dirty="0">
-                <a:latin typeface="Verdana"/>
-                <a:cs typeface="Verdana"/>
-              </a:rPr>
-              <a:t> </a:t>
-            </a:r>
-            <a:r>
-              <a:rPr sz="1800" b="1" spc="-5" dirty="0">
-                <a:latin typeface="Verdana"/>
-                <a:cs typeface="Verdana"/>
-              </a:rPr>
-              <a:t>bombilla.on();</a:t>
-            </a:r>
-            <a:endParaRPr sz="1800">
-              <a:latin typeface="Verdana"/>
-              <a:cs typeface="Verdana"/>
-            </a:endParaRPr>
-          </a:p>
-        </p:txBody>
-      </p:sp>
-      <p:pic>
-        <p:nvPicPr>
-          <p:cNvPr id="5" name="object 5">
-            <a:extLst>
-              <a:ext uri="{FF2B5EF4-FFF2-40B4-BE49-F238E27FC236}">
-                <a16:creationId xmlns:a16="http://schemas.microsoft.com/office/drawing/2014/main" id="{B012B65A-472D-355E-EF48-92A0A543F014}"/>
-              </a:ext>
-            </a:extLst>
-          </p:cNvPr>
-          <p:cNvPicPr/>
+          <p:cNvPicPr>
+            <a:picLocks noChangeAspect="1"/>
+          </p:cNvPicPr>
           <p:nvPr/>
         </p:nvPicPr>
         <p:blipFill>
-          <a:blip r:embed="rId3" cstate="print"/>
+          <a:blip r:embed="rId3"/>
           <a:stretch>
             <a:fillRect/>
           </a:stretch>
         </p:blipFill>
         <p:spPr>
           <a:xfrm>
-            <a:off x="6530657" y="5483296"/>
-            <a:ext cx="2304525" cy="1011956"/>
+            <a:off x="1071406" y="2271684"/>
+            <a:ext cx="7566181" cy="3794566"/>
           </a:xfrm>
           <a:prstGeom prst="rect">
             <a:avLst/>
@@ -30802,7 +31336,7 @@
     </p:spTree>
     <p:extLst>
       <p:ext uri="{BB962C8B-B14F-4D97-AF65-F5344CB8AC3E}">
-        <p14:creationId xmlns:p14="http://schemas.microsoft.com/office/powerpoint/2010/main" val="955635252"/>
+        <p14:creationId xmlns:p14="http://schemas.microsoft.com/office/powerpoint/2010/main" val="2075073051"/>
       </p:ext>
     </p:extLst>
   </p:cSld>
@@ -30976,6 +31510,1023 @@
         <p:cNvPr id="1" name="">
           <a:extLst>
             <a:ext uri="{FF2B5EF4-FFF2-40B4-BE49-F238E27FC236}">
+              <a16:creationId xmlns:a16="http://schemas.microsoft.com/office/drawing/2014/main" id="{8D08BF2A-927D-6361-632D-36F6539CF5E2}"/>
+            </a:ext>
+          </a:extLst>
+        </p:cNvPr>
+        <p:cNvGrpSpPr/>
+        <p:nvPr/>
+      </p:nvGrpSpPr>
+      <p:grpSpPr>
+        <a:xfrm>
+          <a:off x="0" y="0"/>
+          <a:ext cx="0" cy="0"/>
+          <a:chOff x="0" y="0"/>
+          <a:chExt cx="0" cy="0"/>
+        </a:xfrm>
+      </p:grpSpPr>
+      <p:sp>
+        <p:nvSpPr>
+          <p:cNvPr id="8194" name="Rectangle 2">
+            <a:extLst>
+              <a:ext uri="{FF2B5EF4-FFF2-40B4-BE49-F238E27FC236}">
+                <a16:creationId xmlns:a16="http://schemas.microsoft.com/office/drawing/2014/main" id="{C03B584E-2E30-31F4-2504-3026D56C82D6}"/>
+              </a:ext>
+            </a:extLst>
+          </p:cNvPr>
+          <p:cNvSpPr>
+            <a:spLocks noGrp="1" noChangeArrowheads="1"/>
+          </p:cNvSpPr>
+          <p:nvPr>
+            <p:ph type="title"/>
+          </p:nvPr>
+        </p:nvSpPr>
+        <p:spPr/>
+        <p:txBody>
+          <a:bodyPr/>
+          <a:lstStyle/>
+          <a:p>
+            <a:pPr eaLnBrk="1" hangingPunct="1"/>
+            <a:r>
+              <a:rPr lang="es-ES" altLang="en-US"/>
+              <a:t>Programación Orientada a Objetos</a:t>
+            </a:r>
+          </a:p>
+        </p:txBody>
+      </p:sp>
+      <p:pic>
+        <p:nvPicPr>
+          <p:cNvPr id="3" name="Imagen 4">
+            <a:extLst>
+              <a:ext uri="{FF2B5EF4-FFF2-40B4-BE49-F238E27FC236}">
+                <a16:creationId xmlns:a16="http://schemas.microsoft.com/office/drawing/2014/main" id="{441E7974-167E-57CF-0509-7A3AEDAEC10F}"/>
+              </a:ext>
+            </a:extLst>
+          </p:cNvPr>
+          <p:cNvPicPr>
+            <a:picLocks noChangeAspect="1"/>
+          </p:cNvPicPr>
+          <p:nvPr/>
+        </p:nvPicPr>
+        <p:blipFill>
+          <a:blip r:embed="rId3"/>
+          <a:stretch>
+            <a:fillRect/>
+          </a:stretch>
+        </p:blipFill>
+        <p:spPr>
+          <a:xfrm>
+            <a:off x="899592" y="2276872"/>
+            <a:ext cx="7867509" cy="3504158"/>
+          </a:xfrm>
+          <a:prstGeom prst="rect">
+            <a:avLst/>
+          </a:prstGeom>
+        </p:spPr>
+      </p:pic>
+    </p:spTree>
+    <p:extLst>
+      <p:ext uri="{BB962C8B-B14F-4D97-AF65-F5344CB8AC3E}">
+        <p14:creationId xmlns:p14="http://schemas.microsoft.com/office/powerpoint/2010/main" val="3878874060"/>
+      </p:ext>
+    </p:extLst>
+  </p:cSld>
+  <p:clrMapOvr>
+    <a:masterClrMapping/>
+  </p:clrMapOvr>
+</p:sld>
+</file>
+
+<file path=ppt/slides/slide41.xml><?xml version="1.0" encoding="utf-8"?>
+<p:sld xmlns:a="http://schemas.openxmlformats.org/drawingml/2006/main" xmlns:r="http://schemas.openxmlformats.org/officeDocument/2006/relationships" xmlns:p="http://schemas.openxmlformats.org/presentationml/2006/main">
+  <p:cSld>
+    <p:spTree>
+      <p:nvGrpSpPr>
+        <p:cNvPr id="1" name="">
+          <a:extLst>
+            <a:ext uri="{FF2B5EF4-FFF2-40B4-BE49-F238E27FC236}">
+              <a16:creationId xmlns:a16="http://schemas.microsoft.com/office/drawing/2014/main" id="{E641250E-153E-4344-E565-4580F78FE3CC}"/>
+            </a:ext>
+          </a:extLst>
+        </p:cNvPr>
+        <p:cNvGrpSpPr/>
+        <p:nvPr/>
+      </p:nvGrpSpPr>
+      <p:grpSpPr>
+        <a:xfrm>
+          <a:off x="0" y="0"/>
+          <a:ext cx="0" cy="0"/>
+          <a:chOff x="0" y="0"/>
+          <a:chExt cx="0" cy="0"/>
+        </a:xfrm>
+      </p:grpSpPr>
+      <p:sp>
+        <p:nvSpPr>
+          <p:cNvPr id="8194" name="Rectangle 2">
+            <a:extLst>
+              <a:ext uri="{FF2B5EF4-FFF2-40B4-BE49-F238E27FC236}">
+                <a16:creationId xmlns:a16="http://schemas.microsoft.com/office/drawing/2014/main" id="{95999ADC-86DF-A832-E00D-0550A0CE1AA8}"/>
+              </a:ext>
+            </a:extLst>
+          </p:cNvPr>
+          <p:cNvSpPr>
+            <a:spLocks noGrp="1" noChangeArrowheads="1"/>
+          </p:cNvSpPr>
+          <p:nvPr>
+            <p:ph type="title"/>
+          </p:nvPr>
+        </p:nvSpPr>
+        <p:spPr/>
+        <p:txBody>
+          <a:bodyPr/>
+          <a:lstStyle/>
+          <a:p>
+            <a:pPr eaLnBrk="1" hangingPunct="1"/>
+            <a:r>
+              <a:rPr lang="es-ES" altLang="en-US"/>
+              <a:t>Programación Orientada a Objetos</a:t>
+            </a:r>
+          </a:p>
+        </p:txBody>
+      </p:sp>
+      <p:pic>
+        <p:nvPicPr>
+          <p:cNvPr id="3" name="Imagen 3">
+            <a:extLst>
+              <a:ext uri="{FF2B5EF4-FFF2-40B4-BE49-F238E27FC236}">
+                <a16:creationId xmlns:a16="http://schemas.microsoft.com/office/drawing/2014/main" id="{4DBD2545-18F6-E74C-E43A-D17EFF0CAD5D}"/>
+              </a:ext>
+            </a:extLst>
+          </p:cNvPr>
+          <p:cNvPicPr>
+            <a:picLocks noChangeAspect="1"/>
+          </p:cNvPicPr>
+          <p:nvPr/>
+        </p:nvPicPr>
+        <p:blipFill>
+          <a:blip r:embed="rId3"/>
+          <a:stretch>
+            <a:fillRect/>
+          </a:stretch>
+        </p:blipFill>
+        <p:spPr>
+          <a:xfrm>
+            <a:off x="1043608" y="2060848"/>
+            <a:ext cx="7686937" cy="4401454"/>
+          </a:xfrm>
+          <a:prstGeom prst="rect">
+            <a:avLst/>
+          </a:prstGeom>
+        </p:spPr>
+      </p:pic>
+    </p:spTree>
+    <p:extLst>
+      <p:ext uri="{BB962C8B-B14F-4D97-AF65-F5344CB8AC3E}">
+        <p14:creationId xmlns:p14="http://schemas.microsoft.com/office/powerpoint/2010/main" val="3521252694"/>
+      </p:ext>
+    </p:extLst>
+  </p:cSld>
+  <p:clrMapOvr>
+    <a:masterClrMapping/>
+  </p:clrMapOvr>
+</p:sld>
+</file>
+
+<file path=ppt/slides/slide42.xml><?xml version="1.0" encoding="utf-8"?>
+<p:sld xmlns:a="http://schemas.openxmlformats.org/drawingml/2006/main" xmlns:r="http://schemas.openxmlformats.org/officeDocument/2006/relationships" xmlns:p="http://schemas.openxmlformats.org/presentationml/2006/main">
+  <p:cSld>
+    <p:spTree>
+      <p:nvGrpSpPr>
+        <p:cNvPr id="1" name="">
+          <a:extLst>
+            <a:ext uri="{FF2B5EF4-FFF2-40B4-BE49-F238E27FC236}">
+              <a16:creationId xmlns:a16="http://schemas.microsoft.com/office/drawing/2014/main" id="{E4E5E110-0A8A-16C1-F965-52A078A8C80F}"/>
+            </a:ext>
+          </a:extLst>
+        </p:cNvPr>
+        <p:cNvGrpSpPr/>
+        <p:nvPr/>
+      </p:nvGrpSpPr>
+      <p:grpSpPr>
+        <a:xfrm>
+          <a:off x="0" y="0"/>
+          <a:ext cx="0" cy="0"/>
+          <a:chOff x="0" y="0"/>
+          <a:chExt cx="0" cy="0"/>
+        </a:xfrm>
+      </p:grpSpPr>
+      <p:sp>
+        <p:nvSpPr>
+          <p:cNvPr id="8194" name="Rectangle 2">
+            <a:extLst>
+              <a:ext uri="{FF2B5EF4-FFF2-40B4-BE49-F238E27FC236}">
+                <a16:creationId xmlns:a16="http://schemas.microsoft.com/office/drawing/2014/main" id="{F150B01C-B4B7-AC6E-8F16-CD3D9B2B98AE}"/>
+              </a:ext>
+            </a:extLst>
+          </p:cNvPr>
+          <p:cNvSpPr>
+            <a:spLocks noGrp="1" noChangeArrowheads="1"/>
+          </p:cNvSpPr>
+          <p:nvPr>
+            <p:ph type="title"/>
+          </p:nvPr>
+        </p:nvSpPr>
+        <p:spPr/>
+        <p:txBody>
+          <a:bodyPr/>
+          <a:lstStyle/>
+          <a:p>
+            <a:pPr eaLnBrk="1" hangingPunct="1"/>
+            <a:r>
+              <a:rPr lang="es-ES" altLang="en-US"/>
+              <a:t>Programación Orientada a Objetos</a:t>
+            </a:r>
+          </a:p>
+        </p:txBody>
+      </p:sp>
+      <p:pic>
+        <p:nvPicPr>
+          <p:cNvPr id="2" name="Imagen 7">
+            <a:extLst>
+              <a:ext uri="{FF2B5EF4-FFF2-40B4-BE49-F238E27FC236}">
+                <a16:creationId xmlns:a16="http://schemas.microsoft.com/office/drawing/2014/main" id="{9273B21C-6899-949B-35BA-53D6EC2206E1}"/>
+              </a:ext>
+            </a:extLst>
+          </p:cNvPr>
+          <p:cNvPicPr>
+            <a:picLocks noChangeAspect="1"/>
+          </p:cNvPicPr>
+          <p:nvPr/>
+        </p:nvPicPr>
+        <p:blipFill>
+          <a:blip r:embed="rId3"/>
+          <a:stretch>
+            <a:fillRect/>
+          </a:stretch>
+        </p:blipFill>
+        <p:spPr>
+          <a:xfrm>
+            <a:off x="914400" y="2204864"/>
+            <a:ext cx="7635115" cy="3750465"/>
+          </a:xfrm>
+          <a:prstGeom prst="rect">
+            <a:avLst/>
+          </a:prstGeom>
+        </p:spPr>
+      </p:pic>
+    </p:spTree>
+    <p:extLst>
+      <p:ext uri="{BB962C8B-B14F-4D97-AF65-F5344CB8AC3E}">
+        <p14:creationId xmlns:p14="http://schemas.microsoft.com/office/powerpoint/2010/main" val="3666961221"/>
+      </p:ext>
+    </p:extLst>
+  </p:cSld>
+  <p:clrMapOvr>
+    <a:masterClrMapping/>
+  </p:clrMapOvr>
+</p:sld>
+</file>
+
+<file path=ppt/slides/slide43.xml><?xml version="1.0" encoding="utf-8"?>
+<p:sld xmlns:a="http://schemas.openxmlformats.org/drawingml/2006/main" xmlns:r="http://schemas.openxmlformats.org/officeDocument/2006/relationships" xmlns:p="http://schemas.openxmlformats.org/presentationml/2006/main">
+  <p:cSld>
+    <p:spTree>
+      <p:nvGrpSpPr>
+        <p:cNvPr id="1" name="">
+          <a:extLst>
+            <a:ext uri="{FF2B5EF4-FFF2-40B4-BE49-F238E27FC236}">
+              <a16:creationId xmlns:a16="http://schemas.microsoft.com/office/drawing/2014/main" id="{9CC41E07-E489-FFA5-4FC8-A97172CF0F2F}"/>
+            </a:ext>
+          </a:extLst>
+        </p:cNvPr>
+        <p:cNvGrpSpPr/>
+        <p:nvPr/>
+      </p:nvGrpSpPr>
+      <p:grpSpPr>
+        <a:xfrm>
+          <a:off x="0" y="0"/>
+          <a:ext cx="0" cy="0"/>
+          <a:chOff x="0" y="0"/>
+          <a:chExt cx="0" cy="0"/>
+        </a:xfrm>
+      </p:grpSpPr>
+      <p:sp>
+        <p:nvSpPr>
+          <p:cNvPr id="8194" name="Rectangle 2">
+            <a:extLst>
+              <a:ext uri="{FF2B5EF4-FFF2-40B4-BE49-F238E27FC236}">
+                <a16:creationId xmlns:a16="http://schemas.microsoft.com/office/drawing/2014/main" id="{4FA70FC8-05A1-4A90-B578-61641BFFF1FB}"/>
+              </a:ext>
+            </a:extLst>
+          </p:cNvPr>
+          <p:cNvSpPr>
+            <a:spLocks noGrp="1" noChangeArrowheads="1"/>
+          </p:cNvSpPr>
+          <p:nvPr>
+            <p:ph type="title"/>
+          </p:nvPr>
+        </p:nvSpPr>
+        <p:spPr/>
+        <p:txBody>
+          <a:bodyPr/>
+          <a:lstStyle/>
+          <a:p>
+            <a:pPr eaLnBrk="1" hangingPunct="1"/>
+            <a:r>
+              <a:rPr lang="es-ES" altLang="en-US"/>
+              <a:t>Programación Orientada a Objetos</a:t>
+            </a:r>
+          </a:p>
+        </p:txBody>
+      </p:sp>
+      <p:sp>
+        <p:nvSpPr>
+          <p:cNvPr id="3" name="object 3">
+            <a:extLst>
+              <a:ext uri="{FF2B5EF4-FFF2-40B4-BE49-F238E27FC236}">
+                <a16:creationId xmlns:a16="http://schemas.microsoft.com/office/drawing/2014/main" id="{DECB7BB4-B31F-10CC-8A6F-087587099716}"/>
+              </a:ext>
+            </a:extLst>
+          </p:cNvPr>
+          <p:cNvSpPr txBox="1"/>
+          <p:nvPr/>
+        </p:nvSpPr>
+        <p:spPr>
+          <a:xfrm>
+            <a:off x="1043608" y="1846106"/>
+            <a:ext cx="7166561" cy="3726661"/>
+          </a:xfrm>
+          <a:prstGeom prst="rect">
+            <a:avLst/>
+          </a:prstGeom>
+        </p:spPr>
+        <p:txBody>
+          <a:bodyPr vert="horz" wrap="square" lIns="0" tIns="12700" rIns="0" bIns="0" rtlCol="0">
+            <a:spAutoFit/>
+          </a:bodyPr>
+          <a:lstStyle/>
+          <a:p>
+            <a:pPr marL="12700">
+              <a:lnSpc>
+                <a:spcPct val="100000"/>
+              </a:lnSpc>
+              <a:spcBef>
+                <a:spcPts val="100"/>
+              </a:spcBef>
+            </a:pPr>
+            <a:r>
+              <a:rPr sz="2000" b="1" spc="-10" dirty="0">
+                <a:latin typeface="Verdana"/>
+                <a:cs typeface="Verdana"/>
+              </a:rPr>
+              <a:t>Clases</a:t>
+            </a:r>
+            <a:r>
+              <a:rPr sz="2000" b="1" spc="-5" dirty="0">
+                <a:latin typeface="Verdana"/>
+                <a:cs typeface="Verdana"/>
+              </a:rPr>
+              <a:t> </a:t>
+            </a:r>
+            <a:r>
+              <a:rPr sz="2000" b="1" dirty="0">
+                <a:latin typeface="Verdana"/>
+                <a:cs typeface="Verdana"/>
+              </a:rPr>
+              <a:t>y</a:t>
+            </a:r>
+            <a:r>
+              <a:rPr sz="2000" b="1" spc="-5" dirty="0">
+                <a:latin typeface="Verdana"/>
+                <a:cs typeface="Verdana"/>
+              </a:rPr>
+              <a:t> objetos</a:t>
+            </a:r>
+            <a:endParaRPr sz="2000" dirty="0">
+              <a:latin typeface="Verdana"/>
+              <a:cs typeface="Verdana"/>
+            </a:endParaRPr>
+          </a:p>
+          <a:p>
+            <a:pPr>
+              <a:lnSpc>
+                <a:spcPct val="100000"/>
+              </a:lnSpc>
+              <a:spcBef>
+                <a:spcPts val="15"/>
+              </a:spcBef>
+            </a:pPr>
+            <a:endParaRPr sz="2750" dirty="0">
+              <a:latin typeface="Verdana"/>
+              <a:cs typeface="Verdana"/>
+            </a:endParaRPr>
+          </a:p>
+          <a:p>
+            <a:pPr marL="355600" marR="5080" indent="-342900" algn="just">
+              <a:lnSpc>
+                <a:spcPct val="100000"/>
+              </a:lnSpc>
+              <a:buClr>
+                <a:srgbClr val="D32D50"/>
+              </a:buClr>
+              <a:buFont typeface="Wingdings"/>
+              <a:buChar char=""/>
+              <a:tabLst>
+                <a:tab pos="355600" algn="l"/>
+              </a:tabLst>
+            </a:pPr>
+            <a:r>
+              <a:rPr sz="2000" b="1" dirty="0">
+                <a:latin typeface="Verdana"/>
+                <a:cs typeface="Verdana"/>
+              </a:rPr>
+              <a:t>La</a:t>
+            </a:r>
+            <a:r>
+              <a:rPr sz="2000" b="1" spc="5" dirty="0">
+                <a:latin typeface="Verdana"/>
+                <a:cs typeface="Verdana"/>
+              </a:rPr>
+              <a:t> </a:t>
+            </a:r>
+            <a:r>
+              <a:rPr sz="2000" b="1" spc="-5" dirty="0">
+                <a:latin typeface="Verdana"/>
+                <a:cs typeface="Verdana"/>
+              </a:rPr>
+              <a:t>interfaz</a:t>
+            </a:r>
+            <a:r>
+              <a:rPr sz="2000" b="1" dirty="0">
+                <a:latin typeface="Verdana"/>
+                <a:cs typeface="Verdana"/>
+              </a:rPr>
+              <a:t> ofrece</a:t>
+            </a:r>
+            <a:r>
+              <a:rPr sz="2000" b="1" spc="5" dirty="0">
+                <a:latin typeface="Verdana"/>
+                <a:cs typeface="Verdana"/>
+              </a:rPr>
+              <a:t> </a:t>
+            </a:r>
+            <a:r>
+              <a:rPr sz="2000" b="1" spc="-5" dirty="0">
+                <a:latin typeface="Verdana"/>
+                <a:cs typeface="Verdana"/>
+              </a:rPr>
+              <a:t>al</a:t>
+            </a:r>
+            <a:r>
+              <a:rPr sz="2000" b="1" dirty="0">
+                <a:latin typeface="Verdana"/>
+                <a:cs typeface="Verdana"/>
+              </a:rPr>
+              <a:t> </a:t>
+            </a:r>
+            <a:r>
+              <a:rPr sz="2000" b="1" spc="-5" dirty="0">
+                <a:latin typeface="Verdana"/>
+                <a:cs typeface="Verdana"/>
+              </a:rPr>
+              <a:t>exterior</a:t>
+            </a:r>
+            <a:r>
+              <a:rPr sz="2000" b="1" dirty="0">
+                <a:latin typeface="Verdana"/>
+                <a:cs typeface="Verdana"/>
+              </a:rPr>
+              <a:t> el</a:t>
+            </a:r>
+            <a:r>
+              <a:rPr sz="2000" b="1" spc="5" dirty="0">
+                <a:latin typeface="Verdana"/>
+                <a:cs typeface="Verdana"/>
+              </a:rPr>
+              <a:t> </a:t>
+            </a:r>
+            <a:r>
+              <a:rPr sz="2000" b="1" spc="-5" dirty="0">
+                <a:latin typeface="Verdana"/>
+                <a:cs typeface="Verdana"/>
+              </a:rPr>
+              <a:t>comportamiento</a:t>
+            </a:r>
+            <a:r>
+              <a:rPr sz="2000" b="1" dirty="0">
+                <a:latin typeface="Verdana"/>
+                <a:cs typeface="Verdana"/>
+              </a:rPr>
+              <a:t> </a:t>
+            </a:r>
+            <a:r>
+              <a:rPr sz="2000" b="1" spc="-10" dirty="0">
+                <a:latin typeface="Verdana"/>
+                <a:cs typeface="Verdana"/>
+              </a:rPr>
+              <a:t>del </a:t>
+            </a:r>
+            <a:r>
+              <a:rPr sz="2000" b="1" spc="-5" dirty="0">
+                <a:latin typeface="Verdana"/>
+                <a:cs typeface="Verdana"/>
+              </a:rPr>
+              <a:t> objeto. </a:t>
+            </a:r>
+            <a:r>
+              <a:rPr sz="2000" b="1" spc="-10" dirty="0">
+                <a:latin typeface="Verdana"/>
+                <a:cs typeface="Verdana"/>
+              </a:rPr>
+              <a:t>El </a:t>
+            </a:r>
+            <a:r>
+              <a:rPr sz="2000" b="1" spc="-5" dirty="0">
+                <a:latin typeface="Verdana"/>
+                <a:cs typeface="Verdana"/>
+              </a:rPr>
+              <a:t>código </a:t>
+            </a:r>
+            <a:r>
+              <a:rPr sz="2000" b="1" dirty="0">
+                <a:latin typeface="Verdana"/>
+                <a:cs typeface="Verdana"/>
+              </a:rPr>
+              <a:t>y </a:t>
+            </a:r>
+            <a:r>
+              <a:rPr sz="2000" b="1" spc="-5" dirty="0">
+                <a:latin typeface="Verdana"/>
+                <a:cs typeface="Verdana"/>
+              </a:rPr>
+              <a:t>los </a:t>
+            </a:r>
+            <a:r>
+              <a:rPr sz="2000" b="1" dirty="0">
+                <a:latin typeface="Verdana"/>
+                <a:cs typeface="Verdana"/>
+              </a:rPr>
+              <a:t>datos internos </a:t>
+            </a:r>
+            <a:r>
+              <a:rPr sz="2000" b="1" spc="-5" dirty="0">
+                <a:latin typeface="Verdana"/>
+                <a:cs typeface="Verdana"/>
+              </a:rPr>
+              <a:t>que </a:t>
+            </a:r>
+            <a:r>
+              <a:rPr sz="2000" b="1" dirty="0">
+                <a:latin typeface="Verdana"/>
+                <a:cs typeface="Verdana"/>
+              </a:rPr>
+              <a:t>se </a:t>
+            </a:r>
+            <a:r>
+              <a:rPr sz="2000" b="1" spc="-5" dirty="0">
+                <a:latin typeface="Verdana"/>
+                <a:cs typeface="Verdana"/>
+              </a:rPr>
+              <a:t>utilizan para </a:t>
+            </a:r>
+            <a:r>
+              <a:rPr sz="2000" b="1" dirty="0">
+                <a:latin typeface="Verdana"/>
+                <a:cs typeface="Verdana"/>
+              </a:rPr>
+              <a:t> </a:t>
+            </a:r>
+            <a:r>
+              <a:rPr sz="2000" b="1" spc="-5" dirty="0">
+                <a:latin typeface="Verdana"/>
+                <a:cs typeface="Verdana"/>
+              </a:rPr>
+              <a:t>responder</a:t>
+            </a:r>
+            <a:r>
+              <a:rPr sz="2000" b="1" dirty="0">
+                <a:latin typeface="Verdana"/>
+                <a:cs typeface="Verdana"/>
+              </a:rPr>
+              <a:t> </a:t>
+            </a:r>
+            <a:r>
+              <a:rPr sz="2000" b="1" spc="-5" dirty="0">
+                <a:latin typeface="Verdana"/>
+                <a:cs typeface="Verdana"/>
+              </a:rPr>
+              <a:t>a</a:t>
+            </a:r>
+            <a:r>
+              <a:rPr sz="2000" b="1" spc="20" dirty="0">
+                <a:latin typeface="Verdana"/>
+                <a:cs typeface="Verdana"/>
+              </a:rPr>
+              <a:t> </a:t>
+            </a:r>
+            <a:r>
+              <a:rPr sz="2000" b="1" spc="-5" dirty="0">
+                <a:latin typeface="Verdana"/>
+                <a:cs typeface="Verdana"/>
+              </a:rPr>
+              <a:t>una</a:t>
+            </a:r>
+            <a:r>
+              <a:rPr sz="2000" b="1" dirty="0">
+                <a:latin typeface="Verdana"/>
+                <a:cs typeface="Verdana"/>
+              </a:rPr>
+              <a:t> </a:t>
+            </a:r>
+            <a:r>
+              <a:rPr sz="2000" b="1" spc="-5" dirty="0">
+                <a:latin typeface="Verdana"/>
+                <a:cs typeface="Verdana"/>
+              </a:rPr>
+              <a:t>petición</a:t>
+            </a:r>
+            <a:r>
+              <a:rPr sz="2000" b="1" spc="15" dirty="0">
+                <a:latin typeface="Verdana"/>
+                <a:cs typeface="Verdana"/>
+              </a:rPr>
+              <a:t> </a:t>
+            </a:r>
+            <a:r>
+              <a:rPr sz="2000" b="1" spc="-10" dirty="0">
+                <a:latin typeface="Verdana"/>
+                <a:cs typeface="Verdana"/>
+              </a:rPr>
+              <a:t>se</a:t>
+            </a:r>
+            <a:r>
+              <a:rPr sz="2000" b="1" spc="5" dirty="0">
+                <a:latin typeface="Verdana"/>
+                <a:cs typeface="Verdana"/>
+              </a:rPr>
+              <a:t> </a:t>
+            </a:r>
+            <a:r>
+              <a:rPr sz="2000" b="1" spc="-5" dirty="0">
+                <a:latin typeface="Verdana"/>
+                <a:cs typeface="Verdana"/>
+              </a:rPr>
+              <a:t>denomina</a:t>
+            </a:r>
+            <a:r>
+              <a:rPr sz="2000" b="1" spc="20" dirty="0">
+                <a:latin typeface="Verdana"/>
+                <a:cs typeface="Verdana"/>
+              </a:rPr>
+              <a:t> </a:t>
+            </a:r>
+            <a:r>
+              <a:rPr sz="2000" b="1" spc="-5" dirty="0">
+                <a:latin typeface="Verdana"/>
+                <a:cs typeface="Verdana"/>
+              </a:rPr>
+              <a:t>implementación</a:t>
+            </a:r>
+            <a:endParaRPr sz="2000" dirty="0">
+              <a:latin typeface="Verdana"/>
+              <a:cs typeface="Verdana"/>
+            </a:endParaRPr>
+          </a:p>
+          <a:p>
+            <a:pPr>
+              <a:lnSpc>
+                <a:spcPct val="100000"/>
+              </a:lnSpc>
+              <a:spcBef>
+                <a:spcPts val="20"/>
+              </a:spcBef>
+              <a:buClr>
+                <a:srgbClr val="D32D50"/>
+              </a:buClr>
+              <a:buFont typeface="Wingdings"/>
+              <a:buChar char=""/>
+            </a:pPr>
+            <a:endParaRPr sz="2750" dirty="0">
+              <a:latin typeface="Verdana"/>
+              <a:cs typeface="Verdana"/>
+            </a:endParaRPr>
+          </a:p>
+          <a:p>
+            <a:pPr marL="355600" indent="-342900">
+              <a:lnSpc>
+                <a:spcPct val="100000"/>
+              </a:lnSpc>
+              <a:buClr>
+                <a:srgbClr val="D32D50"/>
+              </a:buClr>
+              <a:buFont typeface="Wingdings"/>
+              <a:buChar char=""/>
+              <a:tabLst>
+                <a:tab pos="354965" algn="l"/>
+                <a:tab pos="355600" algn="l"/>
+              </a:tabLst>
+            </a:pPr>
+            <a:r>
+              <a:rPr sz="2000" b="1" spc="-5" dirty="0">
+                <a:latin typeface="Verdana"/>
+                <a:cs typeface="Verdana"/>
+              </a:rPr>
+              <a:t>Un</a:t>
+            </a:r>
+            <a:r>
+              <a:rPr sz="2000" b="1" spc="-20" dirty="0">
+                <a:latin typeface="Verdana"/>
+                <a:cs typeface="Verdana"/>
+              </a:rPr>
+              <a:t> </a:t>
+            </a:r>
+            <a:r>
+              <a:rPr sz="2000" b="1" spc="-5" dirty="0">
+                <a:latin typeface="Verdana"/>
+                <a:cs typeface="Verdana"/>
+              </a:rPr>
+              <a:t>objeto </a:t>
+            </a:r>
+            <a:r>
+              <a:rPr sz="2000" b="1" spc="-10" dirty="0">
+                <a:latin typeface="Verdana"/>
+                <a:cs typeface="Verdana"/>
+              </a:rPr>
+              <a:t>se</a:t>
+            </a:r>
+            <a:r>
+              <a:rPr sz="2000" b="1" dirty="0">
+                <a:latin typeface="Verdana"/>
+                <a:cs typeface="Verdana"/>
+              </a:rPr>
+              <a:t> </a:t>
+            </a:r>
+            <a:r>
+              <a:rPr sz="2000" b="1" spc="-5" dirty="0">
+                <a:latin typeface="Verdana"/>
+                <a:cs typeface="Verdana"/>
+              </a:rPr>
+              <a:t>compone</a:t>
+            </a:r>
+            <a:r>
+              <a:rPr sz="2000" b="1" spc="-40" dirty="0">
+                <a:latin typeface="Verdana"/>
+                <a:cs typeface="Verdana"/>
+              </a:rPr>
+              <a:t> </a:t>
+            </a:r>
+            <a:r>
+              <a:rPr sz="2000" b="1" spc="-10" dirty="0">
+                <a:latin typeface="Verdana"/>
+                <a:cs typeface="Verdana"/>
+              </a:rPr>
+              <a:t>de:</a:t>
+            </a:r>
+            <a:endParaRPr sz="2000" dirty="0">
+              <a:latin typeface="Verdana"/>
+              <a:cs typeface="Verdana"/>
+            </a:endParaRPr>
+          </a:p>
+          <a:p>
+            <a:pPr>
+              <a:lnSpc>
+                <a:spcPct val="100000"/>
+              </a:lnSpc>
+              <a:spcBef>
+                <a:spcPts val="35"/>
+              </a:spcBef>
+              <a:buClr>
+                <a:srgbClr val="D32D50"/>
+              </a:buClr>
+              <a:buFont typeface="Wingdings"/>
+              <a:buChar char=""/>
+            </a:pPr>
+            <a:endParaRPr sz="2700" dirty="0">
+              <a:latin typeface="Verdana"/>
+              <a:cs typeface="Verdana"/>
+            </a:endParaRPr>
+          </a:p>
+          <a:p>
+            <a:pPr marL="756920" lvl="1" indent="-287020">
+              <a:lnSpc>
+                <a:spcPct val="100000"/>
+              </a:lnSpc>
+              <a:spcBef>
+                <a:spcPts val="5"/>
+              </a:spcBef>
+              <a:buClr>
+                <a:srgbClr val="D32D50"/>
+              </a:buClr>
+              <a:buFont typeface="Wingdings"/>
+              <a:buChar char=""/>
+              <a:tabLst>
+                <a:tab pos="756920" algn="l"/>
+              </a:tabLst>
+            </a:pPr>
+            <a:r>
+              <a:rPr sz="1800" b="1" spc="-5" dirty="0">
+                <a:latin typeface="Verdana"/>
+                <a:cs typeface="Verdana"/>
+              </a:rPr>
+              <a:t>Interfaz:</a:t>
+            </a:r>
+            <a:r>
+              <a:rPr sz="1800" b="1" spc="-10" dirty="0">
+                <a:latin typeface="Verdana"/>
+                <a:cs typeface="Verdana"/>
+              </a:rPr>
+              <a:t> </a:t>
+            </a:r>
+            <a:r>
+              <a:rPr sz="1800" b="1" spc="-5" dirty="0">
+                <a:latin typeface="Verdana"/>
+                <a:cs typeface="Verdana"/>
+              </a:rPr>
+              <a:t>qué </a:t>
+            </a:r>
+            <a:r>
+              <a:rPr sz="1800" b="1" spc="-10" dirty="0">
+                <a:latin typeface="Verdana"/>
+                <a:cs typeface="Verdana"/>
+              </a:rPr>
+              <a:t>se</a:t>
+            </a:r>
+            <a:r>
+              <a:rPr sz="1800" b="1" dirty="0">
+                <a:latin typeface="Verdana"/>
+                <a:cs typeface="Verdana"/>
+              </a:rPr>
+              <a:t> ofrece</a:t>
+            </a:r>
+            <a:endParaRPr sz="1800" dirty="0">
+              <a:latin typeface="Verdana"/>
+              <a:cs typeface="Verdana"/>
+            </a:endParaRPr>
+          </a:p>
+          <a:p>
+            <a:pPr marL="756920" lvl="1" indent="-287020">
+              <a:lnSpc>
+                <a:spcPct val="100000"/>
+              </a:lnSpc>
+              <a:spcBef>
+                <a:spcPts val="439"/>
+              </a:spcBef>
+              <a:buClr>
+                <a:srgbClr val="D32D50"/>
+              </a:buClr>
+              <a:buFont typeface="Wingdings"/>
+              <a:buChar char=""/>
+              <a:tabLst>
+                <a:tab pos="756920" algn="l"/>
+              </a:tabLst>
+            </a:pPr>
+            <a:r>
+              <a:rPr sz="1800" b="1" spc="-5" dirty="0">
+                <a:latin typeface="Verdana"/>
+                <a:cs typeface="Verdana"/>
+              </a:rPr>
+              <a:t>Implementación: cómo</a:t>
+            </a:r>
+            <a:r>
+              <a:rPr sz="1800" b="1" spc="-20" dirty="0">
+                <a:latin typeface="Verdana"/>
+                <a:cs typeface="Verdana"/>
+              </a:rPr>
+              <a:t> </a:t>
+            </a:r>
+            <a:r>
+              <a:rPr sz="1800" b="1" spc="-10" dirty="0">
+                <a:latin typeface="Verdana"/>
+                <a:cs typeface="Verdana"/>
+              </a:rPr>
+              <a:t>se</a:t>
+            </a:r>
+            <a:r>
+              <a:rPr sz="1800" b="1" dirty="0">
+                <a:latin typeface="Verdana"/>
+                <a:cs typeface="Verdana"/>
+              </a:rPr>
+              <a:t> ofrece</a:t>
+            </a:r>
+            <a:endParaRPr sz="1800" dirty="0">
+              <a:latin typeface="Verdana"/>
+              <a:cs typeface="Verdana"/>
+            </a:endParaRPr>
+          </a:p>
+        </p:txBody>
+      </p:sp>
+      <p:sp>
+        <p:nvSpPr>
+          <p:cNvPr id="4" name="object 4">
+            <a:extLst>
+              <a:ext uri="{FF2B5EF4-FFF2-40B4-BE49-F238E27FC236}">
+                <a16:creationId xmlns:a16="http://schemas.microsoft.com/office/drawing/2014/main" id="{4D157B51-07AE-DF4C-C331-2F63A4BA34D0}"/>
+              </a:ext>
+            </a:extLst>
+          </p:cNvPr>
+          <p:cNvSpPr txBox="1"/>
+          <p:nvPr/>
+        </p:nvSpPr>
+        <p:spPr>
+          <a:xfrm>
+            <a:off x="1500809" y="5945667"/>
+            <a:ext cx="3143632" cy="637547"/>
+          </a:xfrm>
+          <a:prstGeom prst="rect">
+            <a:avLst/>
+          </a:prstGeom>
+        </p:spPr>
+        <p:txBody>
+          <a:bodyPr vert="horz" wrap="square" lIns="0" tIns="12700" rIns="0" bIns="0" rtlCol="0">
+            <a:spAutoFit/>
+          </a:bodyPr>
+          <a:lstStyle/>
+          <a:p>
+            <a:pPr marL="12700" marR="5080">
+              <a:lnSpc>
+                <a:spcPct val="119400"/>
+              </a:lnSpc>
+              <a:spcBef>
+                <a:spcPts val="100"/>
+              </a:spcBef>
+            </a:pPr>
+            <a:r>
+              <a:rPr sz="1800" b="1" spc="-5" dirty="0">
+                <a:latin typeface="Verdana"/>
+                <a:cs typeface="Verdana"/>
+              </a:rPr>
+              <a:t>Light bombilla = new Light(); </a:t>
+            </a:r>
+            <a:r>
+              <a:rPr sz="1800" b="1" spc="-605" dirty="0">
+                <a:latin typeface="Verdana"/>
+                <a:cs typeface="Verdana"/>
+              </a:rPr>
+              <a:t> </a:t>
+            </a:r>
+            <a:r>
+              <a:rPr sz="1800" b="1" spc="-5" dirty="0">
+                <a:latin typeface="Verdana"/>
+                <a:cs typeface="Verdana"/>
+              </a:rPr>
+              <a:t>bombilla.on();</a:t>
+            </a:r>
+            <a:endParaRPr sz="1800">
+              <a:latin typeface="Verdana"/>
+              <a:cs typeface="Verdana"/>
+            </a:endParaRPr>
+          </a:p>
+        </p:txBody>
+      </p:sp>
+      <p:pic>
+        <p:nvPicPr>
+          <p:cNvPr id="5" name="object 5">
+            <a:extLst>
+              <a:ext uri="{FF2B5EF4-FFF2-40B4-BE49-F238E27FC236}">
+                <a16:creationId xmlns:a16="http://schemas.microsoft.com/office/drawing/2014/main" id="{B012B65A-472D-355E-EF48-92A0A543F014}"/>
+              </a:ext>
+            </a:extLst>
+          </p:cNvPr>
+          <p:cNvPicPr/>
+          <p:nvPr/>
+        </p:nvPicPr>
+        <p:blipFill>
+          <a:blip r:embed="rId3" cstate="print"/>
+          <a:stretch>
+            <a:fillRect/>
+          </a:stretch>
+        </p:blipFill>
+        <p:spPr>
+          <a:xfrm>
+            <a:off x="6530657" y="5483296"/>
+            <a:ext cx="2304525" cy="1011956"/>
+          </a:xfrm>
+          <a:prstGeom prst="rect">
+            <a:avLst/>
+          </a:prstGeom>
+        </p:spPr>
+      </p:pic>
+    </p:spTree>
+    <p:extLst>
+      <p:ext uri="{BB962C8B-B14F-4D97-AF65-F5344CB8AC3E}">
+        <p14:creationId xmlns:p14="http://schemas.microsoft.com/office/powerpoint/2010/main" val="955635252"/>
+      </p:ext>
+    </p:extLst>
+  </p:cSld>
+  <p:clrMapOvr>
+    <a:masterClrMapping/>
+  </p:clrMapOvr>
+</p:sld>
+</file>
+
+<file path=ppt/slides/slide44.xml><?xml version="1.0" encoding="utf-8"?>
+<p:sld xmlns:a="http://schemas.openxmlformats.org/drawingml/2006/main" xmlns:r="http://schemas.openxmlformats.org/officeDocument/2006/relationships" xmlns:p="http://schemas.openxmlformats.org/presentationml/2006/main">
+  <p:cSld>
+    <p:spTree>
+      <p:nvGrpSpPr>
+        <p:cNvPr id="1" name="">
+          <a:extLst>
+            <a:ext uri="{FF2B5EF4-FFF2-40B4-BE49-F238E27FC236}">
               <a16:creationId xmlns:a16="http://schemas.microsoft.com/office/drawing/2014/main" id="{5779BADA-2720-E824-0DF1-9F3FF4805FD0}"/>
             </a:ext>
           </a:extLst>
@@ -31056,7 +32607,7 @@
 </p:sld>
 </file>
 
-<file path=ppt/slides/slide41.xml><?xml version="1.0" encoding="utf-8"?>
+<file path=ppt/slides/slide45.xml><?xml version="1.0" encoding="utf-8"?>
 <p:sld xmlns:a="http://schemas.openxmlformats.org/drawingml/2006/main" xmlns:r="http://schemas.openxmlformats.org/officeDocument/2006/relationships" xmlns:p="http://schemas.openxmlformats.org/presentationml/2006/main" show="0">
   <p:cSld>
     <p:spTree>
@@ -35658,7 +37209,7 @@
 </p:sld>
 </file>
 
-<file path=ppt/slides/slide42.xml><?xml version="1.0" encoding="utf-8"?>
+<file path=ppt/slides/slide46.xml><?xml version="1.0" encoding="utf-8"?>
 <p:sld xmlns:a="http://schemas.openxmlformats.org/drawingml/2006/main" xmlns:r="http://schemas.openxmlformats.org/officeDocument/2006/relationships" xmlns:p="http://schemas.openxmlformats.org/presentationml/2006/main">
   <p:cSld>
     <p:spTree>
@@ -35856,7 +37407,7 @@
 </p:sld>
 </file>
 
-<file path=ppt/slides/slide43.xml><?xml version="1.0" encoding="utf-8"?>
+<file path=ppt/slides/slide47.xml><?xml version="1.0" encoding="utf-8"?>
 <p:sld xmlns:a="http://schemas.openxmlformats.org/drawingml/2006/main" xmlns:r="http://schemas.openxmlformats.org/officeDocument/2006/relationships" xmlns:p="http://schemas.openxmlformats.org/presentationml/2006/main" show="0">
   <p:cSld>
     <p:spTree>

</xml_diff>